<commit_message>
Add fictional intake evidence and calculated investigation workflow
</commit_message>
<xml_diff>
--- a/Product Docs/InvestigateIQ_Technical_Flow.pptx
+++ b/Product Docs/InvestigateIQ_Technical_Flow.pptx
@@ -605,7 +605,7 @@
           <a:p>
             <a:r>
               <a:rPr lang="en-US" dirty="0"/>
-              <a:t>Show the Human Decision panel. AI can suggest an outcome but cannot submit it. The reviewer can accept or reject individual draft findings and must enter a rationale. pages/2_Investigation_Demo.py lines 352–404 calls data/runtime_db.py record_human_decision. The selected display role is not real authentication.</a:t>
+              <a:t>Show the Human Decision panel. AI can suggest an outcome but cannot submit it. For rebuilt-source cases, the reviewer can accept or reject individual draft findings and choose close, request information or escalate with a rationale. Feature-gated intake cases have a separate calculated review; because original KYC and independent fund-source evidence are missing, it allows only request information or escalate, not no-concern closure. Both paths record a named human action and rationale in runtime SQLite. The selected display role is not real authentication.</a:t>
             </a:r>
             <a:endParaRPr lang="en-US" dirty="0"/>
           </a:p>
@@ -957,7 +957,7 @@
           <a:p>
             <a:r>
               <a:rPr lang="en-US" dirty="0"/>
-              <a:t>This slide describes the current local build, not the still-older public release. Do not imply tests prove fraud accuracy, business value or regulatory compliance. Original uploaded KYC files: zero. Some source account IDs are ambiguous; ACC-1004 has two customer owners, so the code withholds attribution. The fictional matched cases intentionally have unknown external identities. A real rollout needs legal/compliance ownership, data permissions, secure ingestion, monitoring, retention and evaluation.</a:t>
+              <a:t>This slide describes the current local build, not the still-older public release. Do not imply tests prove fraud accuracy, business value or regulatory compliance. Original uploaded KYC files: zero. The feature-gated intake saves only numeric fictional batches with generated sample documents; its runtime cases do not run the existing six-agent/Gemini pipeline. Some source account IDs are ambiguous; ACC-1004 has two customer owners, so the code withholds attribution. The fictional matched cases intentionally have unknown external identities. A real rollout needs legal/compliance ownership, data permissions, secure ingestion, monitoring, retention and evaluation.</a:t>
             </a:r>
             <a:endParaRPr lang="en-US" dirty="0"/>
           </a:p>
@@ -1133,7 +1133,7 @@
           <a:p>
             <a:r>
               <a:rPr lang="en-US" dirty="0"/>
-              <a:t>Practice the one-sentence memory cue. For “Where is the third-party alert code?” answer that incoming_monitor.py calculates a signal from supplied data, but there is no authenticated bank endpoint or durable incoming feed. For “Is it fraud?” answer no: the app identifies activity for review. For “Where is the evidence?” show exact transaction IDs, generated source and chunk text, and the missing-evidence flags in Evidence &amp; RAG. For optional Gemini drafting, show agents/investigation_summary_agent.py; calculated_summary.py is the model-free route.</a:t>
+              <a:t>Practice the one-sentence memory cue. For “Where is the third-party alert code?” answer that incoming_monitor.py calculates a signal from supplied data, but there is no authenticated bank endpoint or durable incoming feed. For the optional numeric-only intake, show data/fictional_intake.py: it validates synthetic rows, saves an isolated packet and creates exact searchable chunks. For “Is it fraud?” answer no: the app identifies activity for review. For “Where is the evidence?” show exact transaction IDs, generated source and chunk text, and the missing-evidence flags in Evidence &amp; RAG. For optional Gemini drafting on source cases, show agents/investigation_summary_agent.py; calculated_summary.py is the model-free route. Intake cases never enter that six-stage drafting path.</a:t>
             </a:r>
             <a:endParaRPr lang="en-US" dirty="0"/>
           </a:p>
@@ -1309,7 +1309,7 @@
           <a:p>
             <a:r>
               <a:rPr lang="en-US" dirty="0"/>
-              <a:t>Walk through this left to right, top row then bottom row. The last box contains supporting views rather than a mandatory sequential step. An investigator can also request more information or close the case, not only escalate.</a:t>
+              <a:t>Walk through this left to right, top row then bottom row. The last box contains supporting views rather than a mandatory sequential step. For rebuilt-source cases, the six-stage workflow can produce a calculated or optional Gemini draft, and a human may request information, close or escalate. Feature-gated fictional-intake cases instead use a separate calculated review of their stored runtime packet: it recomputes the rule, checks hashes and chunks, shows missing original KYC and source-of-funds evidence, and permits only request-for-information or human escalation. Do not imply those cases ran through the six agents or Gemini.</a:t>
             </a:r>
             <a:endParaRPr lang="en-US" dirty="0"/>
           </a:p>
@@ -1397,7 +1397,7 @@
           <a:p>
             <a:r>
               <a:rPr lang="en-US" dirty="0"/>
-              <a:t>If asked “Where is the third-party alert webhook?”, answer directly: there is none. Forty-two alerts are imported from the fictional workbook, and two are calculated from fictional transaction fixtures during the local database build. incoming_monitor.py is a tested calculation component, not an authenticated ingestion service. A real feed needs identity, data contract, validation, deduplication, idempotency and durable storage. Rule Config previews sensitivities; it does not regenerate the alert table.</a:t>
+              <a:t>If asked “Where is the third-party alert webhook?”, answer directly: there is none. Forty-two alerts are imported from the fictional workbook, and two are calculated from fictional transaction fixtures during the local database build. The Rule Lab only recalculates in memory. Separately, ENABLE_FICTIONAL_INTAKE=1 exposes numeric-only course intake: data/fictional_intake.py rejects non-synthetic IDs, stores a qualifying batch in runtime SQLite, generates labeled sample records and exact FTS5 chunks, and the Case Queue opens a separate calculated review. This is not an authenticated upload or real bank feed. A real feed needs identity, contracts, validation, deduplication, secure storage and compliance ownership. Rule Config previews sensitivities; it does not regenerate existing alerts.</a:t>
             </a:r>
             <a:endParaRPr lang="en-US" dirty="0"/>
           </a:p>
@@ -1485,7 +1485,7 @@
           <a:p>
             <a:r>
               <a:rPr lang="en-US" dirty="0"/>
-              <a:t>Use CASE-043 as the safer current-build example: both it and CASE-044 were derived from Rahul’s matched test data, but their hidden proposed outcomes were deliberately omitted. Four incoming rows total INR 1.2 million; six outgoing rows total INR 1.08 million. The source account has a six-month INR 80,000 monthly credit baseline, so incoming is 15 times baseline and outbound is 90 percent of incoming. These are account activity aggregates, not proof that any particular incoming rupee funded a particular outgoing payment. The opening INR 20,000 and ending INR 140,000 balance are fixture assumptions. The right next step is to request original evidence and verify counterparty identities; do not infer legality. CASE-041 remains in the deployed video, but its older captured material is separate and must not be mistaken for this new case.</a:t>
+              <a:t>Use CASE-043 as the safer current-build example: both it and CASE-044 were derived from Rahul’s matched test data, but their hidden proposed outcomes were deliberately omitted. Four incoming rows total INR 1.2 million; six outgoing rows total INR 1.08 million. The source account has a six-month INR 80,000 monthly credit baseline, so incoming is 15 times baseline and outbound is 90 percent of incoming. These are account activity aggregates, not proof that any particular incoming rupee funded a particular outgoing payment. All ten distinct counterparties on completed rows lack mapped customer profiles in this dataset; a mapped profile would not itself prove verified KYC, and other banks may hold records we cannot see. The opening INR 20,000 and ending INR 140,000 balance are fixture assumptions. The right next step is to request original evidence and verify counterparty identities; do not infer legality. CASE-041 remains in the deployed video, but its older captured material is separate and must not be mistaken for this new case.</a:t>
             </a:r>
             <a:endParaRPr lang="en-US" dirty="0"/>
           </a:p>
@@ -1573,7 +1573,7 @@
           <a:p>
             <a:r>
               <a:rPr lang="en-US" dirty="0"/>
-              <a:t>The source SQLite file is rebuilt deterministically from a fictional workbook plus two fictional matched fixtures. The runtime file preserves user actions and audit history. The 1,770 case source records are generated text/row representations, not 1,770 uploaded documents. Original identity uploads remain zero. The workbook has an ACC-1004 collision between CUST-1004 and CUST-0004, so the code warns and withholds ownership-specific conclusions for older cases. Avoid saying the runtime audit is tamper-proof. Code: data/build_database.py, data/case_evidence.py and data/runtime_db.py.</a:t>
+              <a:t>The source SQLite file is rebuilt deterministically from a fictional workbook plus two fictional matched fixtures. The runtime file preserves user actions, audit history and feature-gated fictional intake packets. A saved qualifying intake case has 10 synthetic transaction rows, five labeled generated records, exact paragraph chunks and a separate case-scoped FTS5 index; it is not a real bank upload. The 1,770 source case records are generated text/row representations, not 1,770 uploaded documents. Original identity uploads remain zero. The workbook has an ACC-1004 collision between CUST-1004 and CUST-0004, so the code warns and withholds ownership-specific conclusions for older cases. Avoid saying the runtime audit is tamper-proof. Code: data/build_database.py, data/case_evidence.py, data/fictional_intake.py and data/runtime_db.py.</a:t>
             </a:r>
             <a:endParaRPr lang="en-US" dirty="0"/>
           </a:p>
@@ -1749,7 +1749,7 @@
           <a:p>
             <a:r>
               <a:rPr lang="en-US" dirty="0"/>
-              <a:t>There are two retrieval corpora. For 24 synthetic playbooks, C0 is title plus escalation criteria and body chunks group two sentences. For 1,770 generated case records, paragraph chunks preserve source row IDs, SHA-256, case/customer scope and explicit verification status. Both use FTS5/BM25, not vector embeddings. Generated fictional PAN/OVD samples are deliberately invalid and clearly marked; they are not original KYC scans or independently verified evidence. The Evidence &amp; RAG page lets a professor inspect exact source and chunks on-site. Code: data/knowledge_search.py, data/case_evidence.py, agents/evidence_agent.py, pages/8_Evidence_RAG.py.</a:t>
+              <a:t>The rebuilt source has two retrieval corpora: 24 synthetic playbooks and 1,770 generated case records. Playbook C0 holds title/escalation criteria and body chunks group two sentences. Source-case records use exact paragraph chunks with source row IDs, SHA-256, case/customer scope and verification status. Separately, each saved feature-gated intake packet has five generated records and its own case-scoped FTS5 paragraph index; its calculated review searches that index but does not feed the six-stage/Gemini pipeline. This is keyword retrieval, not vector embeddings. Generated fictional PAN/OVD samples are deliberately invalid and clearly marked; they are not original KYC scans or independently verified evidence. Evidence &amp; RAG exposes exact source and chunks on-site. The review-window link register shows recorded endpoints, customer mappings, dataset KYC fields, original-file counts and link quality; this is ledger visibility, not verified settlement. Code: data/knowledge_search.py, data/case_evidence.py, data/fictional_intake.py, data/fund_flow.py, agents/evidence_agent.py and pages/8_Evidence_RAG.py.</a:t>
             </a:r>
             <a:endParaRPr lang="en-US" dirty="0"/>
           </a:p>
@@ -5908,6 +5908,47 @@
           </a:p>
         </p:txBody>
       </p:sp>
+      <p:sp>
+        <p:nvSpPr>
+          <p:cNvPr id="25" name="Text 23"/>
+          <p:cNvSpPr txBox="1"/>
+          <p:nvPr/>
+        </p:nvSpPr>
+        <p:spPr>
+          <a:xfrm>
+            <a:off x="768096" y="5797296"/>
+            <a:ext cx="10744200" cy="347472"/>
+          </a:xfrm>
+          <a:prstGeom prst="rect">
+            <a:avLst/>
+          </a:prstGeom>
+          <a:noFill/>
+          <a:ln/>
+        </p:spPr>
+        <p:txBody>
+          <a:bodyPr wrap="square" lIns="0" tIns="0" rIns="0" bIns="0" rtlCol="0" anchor="ctr">
+            <a:normAutofit/>
+          </a:bodyPr>
+          <a:lstStyle/>
+          <a:p>
+            <a:pPr indent="0" marL="0">
+              <a:buNone/>
+            </a:pPr>
+            <a:r>
+              <a:rPr lang="en-US" sz="1400" b="1" dirty="0">
+                <a:solidFill>
+                  <a:srgbClr val="A24040"/>
+                </a:solidFill>
+                <a:latin typeface="Arial" pitchFamily="34" charset="0"/>
+                <a:ea typeface="Arial" pitchFamily="34" charset="-122"/>
+                <a:cs typeface="Arial" pitchFamily="34" charset="-120"/>
+              </a:rPr>
+              <a:t>Gated intake cases cannot be closed with no concern while original identity and funds evidence is missing.</a:t>
+            </a:r>
+            <a:endParaRPr lang="en-US" sz="1400" dirty="0"/>
+          </a:p>
+        </p:txBody>
+      </p:sp>
     </p:spTree>
   </p:cSld>
   <p:clrMapOvr>
@@ -8444,7 +8485,7 @@
                 <a:ea typeface="Arial" pitchFamily="34" charset="-122"/>
                 <a:cs typeface="Arial" pitchFamily="34" charset="-120"/>
               </a:rPr>
-              <a:t>Source/chunk inspection</a:t>
+              <a:t>Chunks + Rule Lab + gated intake</a:t>
             </a:r>
             <a:endParaRPr lang="en-US" sz="1200" dirty="0"/>
           </a:p>
@@ -10687,7 +10728,7 @@
                 <a:ea typeface="Arial" pitchFamily="34" charset="-122"/>
                 <a:cs typeface="Arial" pitchFamily="34" charset="-120"/>
               </a:rPr>
-              <a:t>76 automated tests pass.</a:t>
+              <a:t>98 automated tests pass.</a:t>
             </a:r>
             <a:endParaRPr lang="en-US" sz="1600" dirty="0"/>
           </a:p>
@@ -10704,7 +10745,7 @@
                 <a:ea typeface="Arial" pitchFamily="34" charset="-122"/>
                 <a:cs typeface="Arial" pitchFamily="34" charset="-120"/>
               </a:rPr>
-              <a:t>44 fictional alerts; two calculated from matched activity.</a:t>
+              <a:t>44 source alerts, plus optional generated intake cases.</a:t>
             </a:r>
             <a:endParaRPr lang="en-US" sz="1600" dirty="0"/>
           </a:p>
@@ -10721,7 +10762,7 @@
                 <a:ea typeface="Arial" pitchFamily="34" charset="-122"/>
                 <a:cs typeface="Arial" pitchFamily="34" charset="-120"/>
               </a:rPr>
-              <a:t>1,770 inspectable case records, 4,282 case chunks; 24 guidance sources and 57 guidance chunks.</a:t>
+              <a:t>1,770 source case records, 4,282 source chunks; feature-gated intake packets add exact chunks separately.</a:t>
             </a:r>
             <a:endParaRPr lang="en-US" sz="1600" dirty="0"/>
           </a:p>
@@ -12399,7 +12440,7 @@
                 <a:ea typeface="Arial" pitchFamily="34" charset="-122"/>
                 <a:cs typeface="Arial" pitchFamily="34" charset="-120"/>
               </a:rPr>
-              <a:t>The seven code locations to remember</a:t>
+              <a:t>Eight code locations to remember</a:t>
             </a:r>
             <a:endParaRPr lang="en-US" sz="3100" dirty="0"/>
           </a:p>
@@ -12495,8 +12536,8 @@
         </p:nvSpPr>
         <p:spPr>
           <a:xfrm>
-            <a:off x="685800" y="1435608"/>
-            <a:ext cx="384048" cy="384048"/>
+            <a:off x="685800" y="1408176"/>
+            <a:ext cx="365760" cy="365760"/>
           </a:xfrm>
           <a:prstGeom prst="ellipse">
             <a:avLst/>
@@ -12520,8 +12561,8 @@
         </p:nvSpPr>
         <p:spPr>
           <a:xfrm>
-            <a:off x="685800" y="1435608"/>
-            <a:ext cx="384048" cy="384048"/>
+            <a:off x="685800" y="1408176"/>
+            <a:ext cx="365760" cy="365760"/>
           </a:xfrm>
           <a:prstGeom prst="rect">
             <a:avLst/>
@@ -12561,8 +12602,8 @@
         </p:nvSpPr>
         <p:spPr>
           <a:xfrm>
-            <a:off x="1261872" y="1371600"/>
-            <a:ext cx="1216152" cy="457200"/>
+            <a:off x="1261872" y="1344168"/>
+            <a:ext cx="1216152" cy="429768"/>
           </a:xfrm>
           <a:prstGeom prst="rect">
             <a:avLst/>
@@ -12580,7 +12621,7 @@
               <a:buNone/>
             </a:pPr>
             <a:r>
-              <a:rPr lang="en-US" sz="1400" b="1" dirty="0">
+              <a:rPr lang="en-US" sz="1300" b="1" dirty="0">
                 <a:solidFill>
                   <a:srgbClr val="9FE4E5"/>
                 </a:solidFill>
@@ -12590,7 +12631,7 @@
               </a:rPr>
               <a:t>INPUT</a:t>
             </a:r>
-            <a:endParaRPr lang="en-US" sz="1400" dirty="0"/>
+            <a:endParaRPr lang="en-US" sz="1300" dirty="0"/>
           </a:p>
         </p:txBody>
       </p:sp>
@@ -12602,8 +12643,8 @@
         </p:nvSpPr>
         <p:spPr>
           <a:xfrm>
-            <a:off x="2532888" y="1371600"/>
-            <a:ext cx="4078224" cy="457200"/>
+            <a:off x="2532888" y="1344168"/>
+            <a:ext cx="4078224" cy="429768"/>
           </a:xfrm>
           <a:prstGeom prst="rect">
             <a:avLst/>
@@ -12621,7 +12662,7 @@
               <a:buNone/>
             </a:pPr>
             <a:r>
-              <a:rPr lang="en-US" sz="1400" b="1" dirty="0">
+              <a:rPr lang="en-US" sz="1300" b="1" dirty="0">
                 <a:solidFill>
                   <a:srgbClr val="FFFFFF"/>
                 </a:solidFill>
@@ -12631,7 +12672,7 @@
               </a:rPr>
               <a:t>data/build_database.py</a:t>
             </a:r>
-            <a:endParaRPr lang="en-US" sz="1400" dirty="0"/>
+            <a:endParaRPr lang="en-US" sz="1300" dirty="0"/>
           </a:p>
         </p:txBody>
       </p:sp>
@@ -12643,8 +12684,8 @@
         </p:nvSpPr>
         <p:spPr>
           <a:xfrm>
-            <a:off x="6647688" y="1371600"/>
-            <a:ext cx="4846320" cy="457200"/>
+            <a:off x="6647688" y="1344168"/>
+            <a:ext cx="4846320" cy="429768"/>
           </a:xfrm>
           <a:prstGeom prst="rect">
             <a:avLst/>
@@ -12662,7 +12703,7 @@
               <a:buNone/>
             </a:pPr>
             <a:r>
-              <a:rPr lang="en-US" sz="1300" dirty="0">
+              <a:rPr lang="en-US" sz="1200" dirty="0">
                 <a:solidFill>
                   <a:srgbClr val="C4D6E9"/>
                 </a:solidFill>
@@ -12672,25 +12713,403 @@
               </a:rPr>
               <a:t>Builds fictional source rows</a:t>
             </a:r>
+            <a:endParaRPr lang="en-US" sz="1200" dirty="0"/>
+          </a:p>
+        </p:txBody>
+      </p:sp>
+      <p:sp>
+        <p:nvSpPr>
+          <p:cNvPr id="11" name="Shape 9"/>
+          <p:cNvSpPr/>
+          <p:nvPr/>
+        </p:nvSpPr>
+        <p:spPr>
+          <a:xfrm>
+            <a:off x="685800" y="1965960"/>
+            <a:ext cx="365760" cy="365760"/>
+          </a:xfrm>
+          <a:prstGeom prst="ellipse">
+            <a:avLst/>
+          </a:prstGeom>
+          <a:solidFill>
+            <a:srgbClr val="2E67B7"/>
+          </a:solidFill>
+          <a:ln w="12700">
+            <a:solidFill>
+              <a:srgbClr val="2E67B7"/>
+            </a:solidFill>
+            <a:prstDash val="solid"/>
+          </a:ln>
+        </p:spPr>
+      </p:sp>
+      <p:sp>
+        <p:nvSpPr>
+          <p:cNvPr id="12" name="Text 10"/>
+          <p:cNvSpPr txBox="1"/>
+          <p:nvPr/>
+        </p:nvSpPr>
+        <p:spPr>
+          <a:xfrm>
+            <a:off x="685800" y="1965960"/>
+            <a:ext cx="365760" cy="365760"/>
+          </a:xfrm>
+          <a:prstGeom prst="rect">
+            <a:avLst/>
+          </a:prstGeom>
+          <a:noFill/>
+          <a:ln/>
+        </p:spPr>
+        <p:txBody>
+          <a:bodyPr wrap="square" lIns="0" tIns="0" rIns="0" bIns="0" rtlCol="0" anchor="ctr">
+            <a:normAutofit/>
+          </a:bodyPr>
+          <a:lstStyle/>
+          <a:p>
+            <a:pPr algn="ctr" indent="0" marL="0">
+              <a:buNone/>
+            </a:pPr>
+            <a:r>
+              <a:rPr lang="en-US" sz="1700" b="1" dirty="0">
+                <a:solidFill>
+                  <a:srgbClr val="FFFFFF"/>
+                </a:solidFill>
+                <a:latin typeface="Arial" pitchFamily="34" charset="0"/>
+                <a:ea typeface="Arial" pitchFamily="34" charset="-122"/>
+                <a:cs typeface="Arial" pitchFamily="34" charset="-120"/>
+              </a:rPr>
+              <a:t>2</a:t>
+            </a:r>
+            <a:endParaRPr lang="en-US" sz="1700" dirty="0"/>
+          </a:p>
+        </p:txBody>
+      </p:sp>
+      <p:sp>
+        <p:nvSpPr>
+          <p:cNvPr id="13" name="Text 11"/>
+          <p:cNvSpPr txBox="1"/>
+          <p:nvPr/>
+        </p:nvSpPr>
+        <p:spPr>
+          <a:xfrm>
+            <a:off x="1261872" y="1901952"/>
+            <a:ext cx="1216152" cy="429768"/>
+          </a:xfrm>
+          <a:prstGeom prst="rect">
+            <a:avLst/>
+          </a:prstGeom>
+          <a:noFill/>
+          <a:ln/>
+        </p:spPr>
+        <p:txBody>
+          <a:bodyPr wrap="square" lIns="0" tIns="0" rIns="0" bIns="0" rtlCol="0" anchor="ctr">
+            <a:normAutofit/>
+          </a:bodyPr>
+          <a:lstStyle/>
+          <a:p>
+            <a:pPr indent="0" marL="0">
+              <a:buNone/>
+            </a:pPr>
+            <a:r>
+              <a:rPr lang="en-US" sz="1300" b="1" dirty="0">
+                <a:solidFill>
+                  <a:srgbClr val="9FE4E5"/>
+                </a:solidFill>
+                <a:latin typeface="Arial" pitchFamily="34" charset="0"/>
+                <a:ea typeface="Arial" pitchFamily="34" charset="-122"/>
+                <a:cs typeface="Arial" pitchFamily="34" charset="-120"/>
+              </a:rPr>
+              <a:t>INTAKE</a:t>
+            </a:r>
             <a:endParaRPr lang="en-US" sz="1300" dirty="0"/>
           </a:p>
         </p:txBody>
       </p:sp>
       <p:sp>
         <p:nvSpPr>
-          <p:cNvPr id="11" name="Shape 9"/>
-          <p:cNvSpPr/>
-          <p:nvPr/>
-        </p:nvSpPr>
-        <p:spPr>
-          <a:xfrm>
-            <a:off x="685800" y="2066544"/>
-            <a:ext cx="384048" cy="384048"/>
+          <p:cNvPr id="14" name="Text 12"/>
+          <p:cNvSpPr txBox="1"/>
+          <p:nvPr/>
+        </p:nvSpPr>
+        <p:spPr>
+          <a:xfrm>
+            <a:off x="2532888" y="1901952"/>
+            <a:ext cx="4078224" cy="429768"/>
+          </a:xfrm>
+          <a:prstGeom prst="rect">
+            <a:avLst/>
+          </a:prstGeom>
+          <a:noFill/>
+          <a:ln/>
+        </p:spPr>
+        <p:txBody>
+          <a:bodyPr wrap="square" lIns="0" tIns="0" rIns="0" bIns="0" rtlCol="0" anchor="ctr">
+            <a:normAutofit/>
+          </a:bodyPr>
+          <a:lstStyle/>
+          <a:p>
+            <a:pPr indent="0" marL="0">
+              <a:buNone/>
+            </a:pPr>
+            <a:r>
+              <a:rPr lang="en-US" sz="1300" b="1" dirty="0">
+                <a:solidFill>
+                  <a:srgbClr val="FFFFFF"/>
+                </a:solidFill>
+                <a:latin typeface="Arial" pitchFamily="34" charset="0"/>
+                <a:ea typeface="Arial" pitchFamily="34" charset="-122"/>
+                <a:cs typeface="Arial" pitchFamily="34" charset="-120"/>
+              </a:rPr>
+              <a:t>data/fictional_intake.py</a:t>
+            </a:r>
+            <a:endParaRPr lang="en-US" sz="1300" dirty="0"/>
+          </a:p>
+        </p:txBody>
+      </p:sp>
+      <p:sp>
+        <p:nvSpPr>
+          <p:cNvPr id="15" name="Text 13"/>
+          <p:cNvSpPr txBox="1"/>
+          <p:nvPr/>
+        </p:nvSpPr>
+        <p:spPr>
+          <a:xfrm>
+            <a:off x="6647688" y="1901952"/>
+            <a:ext cx="4846320" cy="429768"/>
+          </a:xfrm>
+          <a:prstGeom prst="rect">
+            <a:avLst/>
+          </a:prstGeom>
+          <a:noFill/>
+          <a:ln/>
+        </p:spPr>
+        <p:txBody>
+          <a:bodyPr wrap="square" lIns="0" tIns="0" rIns="0" bIns="0" rtlCol="0" anchor="ctr">
+            <a:normAutofit/>
+          </a:bodyPr>
+          <a:lstStyle/>
+          <a:p>
+            <a:pPr indent="0" marL="0">
+              <a:buNone/>
+            </a:pPr>
+            <a:r>
+              <a:rPr lang="en-US" sz="1200" dirty="0">
+                <a:solidFill>
+                  <a:srgbClr val="C4D6E9"/>
+                </a:solidFill>
+                <a:latin typeface="Arial" pitchFamily="34" charset="0"/>
+                <a:ea typeface="Arial" pitchFamily="34" charset="-122"/>
+                <a:cs typeface="Arial" pitchFamily="34" charset="-120"/>
+              </a:rPr>
+              <a:t>Saves gated synthetic packet + chunks</a:t>
+            </a:r>
+            <a:endParaRPr lang="en-US" sz="1200" dirty="0"/>
+          </a:p>
+        </p:txBody>
+      </p:sp>
+      <p:sp>
+        <p:nvSpPr>
+          <p:cNvPr id="16" name="Shape 14"/>
+          <p:cNvSpPr/>
+          <p:nvPr/>
+        </p:nvSpPr>
+        <p:spPr>
+          <a:xfrm>
+            <a:off x="685800" y="2523744"/>
+            <a:ext cx="365760" cy="365760"/>
           </a:xfrm>
           <a:prstGeom prst="ellipse">
             <a:avLst/>
           </a:prstGeom>
           <a:solidFill>
+            <a:srgbClr val="087E8B"/>
+          </a:solidFill>
+          <a:ln w="12700">
+            <a:solidFill>
+              <a:srgbClr val="087E8B"/>
+            </a:solidFill>
+            <a:prstDash val="solid"/>
+          </a:ln>
+        </p:spPr>
+      </p:sp>
+      <p:sp>
+        <p:nvSpPr>
+          <p:cNvPr id="17" name="Text 15"/>
+          <p:cNvSpPr txBox="1"/>
+          <p:nvPr/>
+        </p:nvSpPr>
+        <p:spPr>
+          <a:xfrm>
+            <a:off x="685800" y="2523744"/>
+            <a:ext cx="365760" cy="365760"/>
+          </a:xfrm>
+          <a:prstGeom prst="rect">
+            <a:avLst/>
+          </a:prstGeom>
+          <a:noFill/>
+          <a:ln/>
+        </p:spPr>
+        <p:txBody>
+          <a:bodyPr wrap="square" lIns="0" tIns="0" rIns="0" bIns="0" rtlCol="0" anchor="ctr">
+            <a:normAutofit/>
+          </a:bodyPr>
+          <a:lstStyle/>
+          <a:p>
+            <a:pPr algn="ctr" indent="0" marL="0">
+              <a:buNone/>
+            </a:pPr>
+            <a:r>
+              <a:rPr lang="en-US" sz="1700" b="1" dirty="0">
+                <a:solidFill>
+                  <a:srgbClr val="FFFFFF"/>
+                </a:solidFill>
+                <a:latin typeface="Arial" pitchFamily="34" charset="0"/>
+                <a:ea typeface="Arial" pitchFamily="34" charset="-122"/>
+                <a:cs typeface="Arial" pitchFamily="34" charset="-120"/>
+              </a:rPr>
+              <a:t>3</a:t>
+            </a:r>
+            <a:endParaRPr lang="en-US" sz="1700" dirty="0"/>
+          </a:p>
+        </p:txBody>
+      </p:sp>
+      <p:sp>
+        <p:nvSpPr>
+          <p:cNvPr id="18" name="Text 16"/>
+          <p:cNvSpPr txBox="1"/>
+          <p:nvPr/>
+        </p:nvSpPr>
+        <p:spPr>
+          <a:xfrm>
+            <a:off x="1261872" y="2459736"/>
+            <a:ext cx="1216152" cy="429768"/>
+          </a:xfrm>
+          <a:prstGeom prst="rect">
+            <a:avLst/>
+          </a:prstGeom>
+          <a:noFill/>
+          <a:ln/>
+        </p:spPr>
+        <p:txBody>
+          <a:bodyPr wrap="square" lIns="0" tIns="0" rIns="0" bIns="0" rtlCol="0" anchor="ctr">
+            <a:normAutofit/>
+          </a:bodyPr>
+          <a:lstStyle/>
+          <a:p>
+            <a:pPr indent="0" marL="0">
+              <a:buNone/>
+            </a:pPr>
+            <a:r>
+              <a:rPr lang="en-US" sz="1300" b="1" dirty="0">
+                <a:solidFill>
+                  <a:srgbClr val="9FE4E5"/>
+                </a:solidFill>
+                <a:latin typeface="Arial" pitchFamily="34" charset="0"/>
+                <a:ea typeface="Arial" pitchFamily="34" charset="-122"/>
+                <a:cs typeface="Arial" pitchFamily="34" charset="-120"/>
+              </a:rPr>
+              <a:t>ALERT</a:t>
+            </a:r>
+            <a:endParaRPr lang="en-US" sz="1300" dirty="0"/>
+          </a:p>
+        </p:txBody>
+      </p:sp>
+      <p:sp>
+        <p:nvSpPr>
+          <p:cNvPr id="19" name="Text 17"/>
+          <p:cNvSpPr txBox="1"/>
+          <p:nvPr/>
+        </p:nvSpPr>
+        <p:spPr>
+          <a:xfrm>
+            <a:off x="2532888" y="2459736"/>
+            <a:ext cx="4078224" cy="429768"/>
+          </a:xfrm>
+          <a:prstGeom prst="rect">
+            <a:avLst/>
+          </a:prstGeom>
+          <a:noFill/>
+          <a:ln/>
+        </p:spPr>
+        <p:txBody>
+          <a:bodyPr wrap="square" lIns="0" tIns="0" rIns="0" bIns="0" rtlCol="0" anchor="ctr">
+            <a:normAutofit/>
+          </a:bodyPr>
+          <a:lstStyle/>
+          <a:p>
+            <a:pPr indent="0" marL="0">
+              <a:buNone/>
+            </a:pPr>
+            <a:r>
+              <a:rPr lang="en-US" sz="1300" b="1" dirty="0">
+                <a:solidFill>
+                  <a:srgbClr val="FFFFFF"/>
+                </a:solidFill>
+                <a:latin typeface="Arial" pitchFamily="34" charset="0"/>
+                <a:ea typeface="Arial" pitchFamily="34" charset="-122"/>
+                <a:cs typeface="Arial" pitchFamily="34" charset="-120"/>
+              </a:rPr>
+              <a:t>data/incoming_monitor.py</a:t>
+            </a:r>
+            <a:endParaRPr lang="en-US" sz="1300" dirty="0"/>
+          </a:p>
+        </p:txBody>
+      </p:sp>
+      <p:sp>
+        <p:nvSpPr>
+          <p:cNvPr id="20" name="Text 18"/>
+          <p:cNvSpPr txBox="1"/>
+          <p:nvPr/>
+        </p:nvSpPr>
+        <p:spPr>
+          <a:xfrm>
+            <a:off x="6647688" y="2459736"/>
+            <a:ext cx="4846320" cy="429768"/>
+          </a:xfrm>
+          <a:prstGeom prst="rect">
+            <a:avLst/>
+          </a:prstGeom>
+          <a:noFill/>
+          <a:ln/>
+        </p:spPr>
+        <p:txBody>
+          <a:bodyPr wrap="square" lIns="0" tIns="0" rIns="0" bIns="0" rtlCol="0" anchor="ctr">
+            <a:normAutofit/>
+          </a:bodyPr>
+          <a:lstStyle/>
+          <a:p>
+            <a:pPr indent="0" marL="0">
+              <a:buNone/>
+            </a:pPr>
+            <a:r>
+              <a:rPr lang="en-US" sz="1200" dirty="0">
+                <a:solidFill>
+                  <a:srgbClr val="C4D6E9"/>
+                </a:solidFill>
+                <a:latin typeface="Arial" pitchFamily="34" charset="0"/>
+                <a:ea typeface="Arial" pitchFamily="34" charset="-122"/>
+                <a:cs typeface="Arial" pitchFamily="34" charset="-120"/>
+              </a:rPr>
+              <a:t>Calculates 24-hour review signal</a:t>
+            </a:r>
+            <a:endParaRPr lang="en-US" sz="1200" dirty="0"/>
+          </a:p>
+        </p:txBody>
+      </p:sp>
+      <p:sp>
+        <p:nvSpPr>
+          <p:cNvPr id="21" name="Shape 19"/>
+          <p:cNvSpPr/>
+          <p:nvPr/>
+        </p:nvSpPr>
+        <p:spPr>
+          <a:xfrm>
+            <a:off x="685800" y="3081528"/>
+            <a:ext cx="365760" cy="365760"/>
+          </a:xfrm>
+          <a:prstGeom prst="ellipse">
+            <a:avLst/>
+          </a:prstGeom>
+          <a:solidFill>
             <a:srgbClr val="2E67B7"/>
           </a:solidFill>
           <a:ln w="12700">
@@ -12703,14 +13122,14 @@
       </p:sp>
       <p:sp>
         <p:nvSpPr>
-          <p:cNvPr id="12" name="Text 10"/>
-          <p:cNvSpPr txBox="1"/>
-          <p:nvPr/>
-        </p:nvSpPr>
-        <p:spPr>
-          <a:xfrm>
-            <a:off x="685800" y="2066544"/>
-            <a:ext cx="384048" cy="384048"/>
+          <p:cNvPr id="22" name="Text 20"/>
+          <p:cNvSpPr txBox="1"/>
+          <p:nvPr/>
+        </p:nvSpPr>
+        <p:spPr>
+          <a:xfrm>
+            <a:off x="685800" y="3081528"/>
+            <a:ext cx="365760" cy="365760"/>
           </a:xfrm>
           <a:prstGeom prst="rect">
             <a:avLst/>
@@ -12736,7 +13155,7 @@
                 <a:ea typeface="Arial" pitchFamily="34" charset="-122"/>
                 <a:cs typeface="Arial" pitchFamily="34" charset="-120"/>
               </a:rPr>
-              <a:t>2</a:t>
+              <a:t>4</a:t>
             </a:r>
             <a:endParaRPr lang="en-US" sz="1700" dirty="0"/>
           </a:p>
@@ -12744,14 +13163,14 @@
       </p:sp>
       <p:sp>
         <p:nvSpPr>
-          <p:cNvPr id="13" name="Text 11"/>
-          <p:cNvSpPr txBox="1"/>
-          <p:nvPr/>
-        </p:nvSpPr>
-        <p:spPr>
-          <a:xfrm>
-            <a:off x="1261872" y="2002536"/>
-            <a:ext cx="1216152" cy="457200"/>
+          <p:cNvPr id="23" name="Text 21"/>
+          <p:cNvSpPr txBox="1"/>
+          <p:nvPr/>
+        </p:nvSpPr>
+        <p:spPr>
+          <a:xfrm>
+            <a:off x="1261872" y="3017520"/>
+            <a:ext cx="1216152" cy="429768"/>
           </a:xfrm>
           <a:prstGeom prst="rect">
             <a:avLst/>
@@ -12769,7 +13188,7 @@
               <a:buNone/>
             </a:pPr>
             <a:r>
-              <a:rPr lang="en-US" sz="1400" b="1" dirty="0">
+              <a:rPr lang="en-US" sz="1300" b="1" dirty="0">
                 <a:solidFill>
                   <a:srgbClr val="9FE4E5"/>
                 </a:solidFill>
@@ -12777,22 +13196,22 @@
                 <a:ea typeface="Arial" pitchFamily="34" charset="-122"/>
                 <a:cs typeface="Arial" pitchFamily="34" charset="-120"/>
               </a:rPr>
-              <a:t>ALERT</a:t>
-            </a:r>
-            <a:endParaRPr lang="en-US" sz="1400" dirty="0"/>
-          </a:p>
-        </p:txBody>
-      </p:sp>
-      <p:sp>
-        <p:nvSpPr>
-          <p:cNvPr id="14" name="Text 12"/>
-          <p:cNvSpPr txBox="1"/>
-          <p:nvPr/>
-        </p:nvSpPr>
-        <p:spPr>
-          <a:xfrm>
-            <a:off x="2532888" y="2002536"/>
-            <a:ext cx="4078224" cy="457200"/>
+              <a:t>FLOW</a:t>
+            </a:r>
+            <a:endParaRPr lang="en-US" sz="1300" dirty="0"/>
+          </a:p>
+        </p:txBody>
+      </p:sp>
+      <p:sp>
+        <p:nvSpPr>
+          <p:cNvPr id="24" name="Text 22"/>
+          <p:cNvSpPr txBox="1"/>
+          <p:nvPr/>
+        </p:nvSpPr>
+        <p:spPr>
+          <a:xfrm>
+            <a:off x="2532888" y="3017520"/>
+            <a:ext cx="4078224" cy="429768"/>
           </a:xfrm>
           <a:prstGeom prst="rect">
             <a:avLst/>
@@ -12810,7 +13229,7 @@
               <a:buNone/>
             </a:pPr>
             <a:r>
-              <a:rPr lang="en-US" sz="1400" b="1" dirty="0">
+              <a:rPr lang="en-US" sz="1300" b="1" dirty="0">
                 <a:solidFill>
                   <a:srgbClr val="FFFFFF"/>
                 </a:solidFill>
@@ -12818,22 +13237,22 @@
                 <a:ea typeface="Arial" pitchFamily="34" charset="-122"/>
                 <a:cs typeface="Arial" pitchFamily="34" charset="-120"/>
               </a:rPr>
-              <a:t>data/incoming_monitor.py</a:t>
-            </a:r>
-            <a:endParaRPr lang="en-US" sz="1400" dirty="0"/>
-          </a:p>
-        </p:txBody>
-      </p:sp>
-      <p:sp>
-        <p:nvSpPr>
-          <p:cNvPr id="15" name="Text 13"/>
-          <p:cNvSpPr txBox="1"/>
-          <p:nvPr/>
-        </p:nvSpPr>
-        <p:spPr>
-          <a:xfrm>
-            <a:off x="6647688" y="2002536"/>
-            <a:ext cx="4846320" cy="457200"/>
+              <a:t>agents/orchestrator.py</a:t>
+            </a:r>
+            <a:endParaRPr lang="en-US" sz="1300" dirty="0"/>
+          </a:p>
+        </p:txBody>
+      </p:sp>
+      <p:sp>
+        <p:nvSpPr>
+          <p:cNvPr id="25" name="Text 23"/>
+          <p:cNvSpPr txBox="1"/>
+          <p:nvPr/>
+        </p:nvSpPr>
+        <p:spPr>
+          <a:xfrm>
+            <a:off x="6647688" y="3017520"/>
+            <a:ext cx="4846320" cy="429768"/>
           </a:xfrm>
           <a:prstGeom prst="rect">
             <a:avLst/>
@@ -12851,7 +13270,7 @@
               <a:buNone/>
             </a:pPr>
             <a:r>
-              <a:rPr lang="en-US" sz="1300" dirty="0">
+              <a:rPr lang="en-US" sz="1200" dirty="0">
                 <a:solidFill>
                   <a:srgbClr val="C4D6E9"/>
                 </a:solidFill>
@@ -12859,7 +13278,114 @@
                 <a:ea typeface="Arial" pitchFamily="34" charset="-122"/>
                 <a:cs typeface="Arial" pitchFamily="34" charset="-120"/>
               </a:rPr>
-              <a:t>Calculates 24-hour review signal</a:t>
+              <a:t>Runs six fixed stages</a:t>
+            </a:r>
+            <a:endParaRPr lang="en-US" sz="1200" dirty="0"/>
+          </a:p>
+        </p:txBody>
+      </p:sp>
+      <p:sp>
+        <p:nvSpPr>
+          <p:cNvPr id="26" name="Shape 24"/>
+          <p:cNvSpPr/>
+          <p:nvPr/>
+        </p:nvSpPr>
+        <p:spPr>
+          <a:xfrm>
+            <a:off x="685800" y="3639312"/>
+            <a:ext cx="365760" cy="365760"/>
+          </a:xfrm>
+          <a:prstGeom prst="ellipse">
+            <a:avLst/>
+          </a:prstGeom>
+          <a:solidFill>
+            <a:srgbClr val="087E8B"/>
+          </a:solidFill>
+          <a:ln w="12700">
+            <a:solidFill>
+              <a:srgbClr val="087E8B"/>
+            </a:solidFill>
+            <a:prstDash val="solid"/>
+          </a:ln>
+        </p:spPr>
+      </p:sp>
+      <p:sp>
+        <p:nvSpPr>
+          <p:cNvPr id="27" name="Text 25"/>
+          <p:cNvSpPr txBox="1"/>
+          <p:nvPr/>
+        </p:nvSpPr>
+        <p:spPr>
+          <a:xfrm>
+            <a:off x="685800" y="3639312"/>
+            <a:ext cx="365760" cy="365760"/>
+          </a:xfrm>
+          <a:prstGeom prst="rect">
+            <a:avLst/>
+          </a:prstGeom>
+          <a:noFill/>
+          <a:ln/>
+        </p:spPr>
+        <p:txBody>
+          <a:bodyPr wrap="square" lIns="0" tIns="0" rIns="0" bIns="0" rtlCol="0" anchor="ctr">
+            <a:normAutofit/>
+          </a:bodyPr>
+          <a:lstStyle/>
+          <a:p>
+            <a:pPr algn="ctr" indent="0" marL="0">
+              <a:buNone/>
+            </a:pPr>
+            <a:r>
+              <a:rPr lang="en-US" sz="1700" b="1" dirty="0">
+                <a:solidFill>
+                  <a:srgbClr val="FFFFFF"/>
+                </a:solidFill>
+                <a:latin typeface="Arial" pitchFamily="34" charset="0"/>
+                <a:ea typeface="Arial" pitchFamily="34" charset="-122"/>
+                <a:cs typeface="Arial" pitchFamily="34" charset="-120"/>
+              </a:rPr>
+              <a:t>5</a:t>
+            </a:r>
+            <a:endParaRPr lang="en-US" sz="1700" dirty="0"/>
+          </a:p>
+        </p:txBody>
+      </p:sp>
+      <p:sp>
+        <p:nvSpPr>
+          <p:cNvPr id="28" name="Text 26"/>
+          <p:cNvSpPr txBox="1"/>
+          <p:nvPr/>
+        </p:nvSpPr>
+        <p:spPr>
+          <a:xfrm>
+            <a:off x="1261872" y="3575304"/>
+            <a:ext cx="1216152" cy="429768"/>
+          </a:xfrm>
+          <a:prstGeom prst="rect">
+            <a:avLst/>
+          </a:prstGeom>
+          <a:noFill/>
+          <a:ln/>
+        </p:spPr>
+        <p:txBody>
+          <a:bodyPr wrap="square" lIns="0" tIns="0" rIns="0" bIns="0" rtlCol="0" anchor="ctr">
+            <a:normAutofit/>
+          </a:bodyPr>
+          <a:lstStyle/>
+          <a:p>
+            <a:pPr indent="0" marL="0">
+              <a:buNone/>
+            </a:pPr>
+            <a:r>
+              <a:rPr lang="en-US" sz="1300" b="1" dirty="0">
+                <a:solidFill>
+                  <a:srgbClr val="9FE4E5"/>
+                </a:solidFill>
+                <a:latin typeface="Arial" pitchFamily="34" charset="0"/>
+                <a:ea typeface="Arial" pitchFamily="34" charset="-122"/>
+                <a:cs typeface="Arial" pitchFamily="34" charset="-120"/>
+              </a:rPr>
+              <a:t>RAG</a:t>
             </a:r>
             <a:endParaRPr lang="en-US" sz="1300" dirty="0"/>
           </a:p>
@@ -12867,19 +13393,290 @@
       </p:sp>
       <p:sp>
         <p:nvSpPr>
-          <p:cNvPr id="16" name="Shape 14"/>
-          <p:cNvSpPr/>
-          <p:nvPr/>
-        </p:nvSpPr>
-        <p:spPr>
-          <a:xfrm>
-            <a:off x="685800" y="2697480"/>
-            <a:ext cx="384048" cy="384048"/>
+          <p:cNvPr id="29" name="Text 27"/>
+          <p:cNvSpPr txBox="1"/>
+          <p:nvPr/>
+        </p:nvSpPr>
+        <p:spPr>
+          <a:xfrm>
+            <a:off x="2532888" y="3575304"/>
+            <a:ext cx="4078224" cy="429768"/>
+          </a:xfrm>
+          <a:prstGeom prst="rect">
+            <a:avLst/>
+          </a:prstGeom>
+          <a:noFill/>
+          <a:ln/>
+        </p:spPr>
+        <p:txBody>
+          <a:bodyPr wrap="square" lIns="0" tIns="0" rIns="0" bIns="0" rtlCol="0" anchor="ctr">
+            <a:normAutofit/>
+          </a:bodyPr>
+          <a:lstStyle/>
+          <a:p>
+            <a:pPr indent="0" marL="0">
+              <a:buNone/>
+            </a:pPr>
+            <a:r>
+              <a:rPr lang="en-US" sz="1300" b="1" dirty="0">
+                <a:solidFill>
+                  <a:srgbClr val="FFFFFF"/>
+                </a:solidFill>
+                <a:latin typeface="Arial" pitchFamily="34" charset="0"/>
+                <a:ea typeface="Arial" pitchFamily="34" charset="-122"/>
+                <a:cs typeface="Arial" pitchFamily="34" charset="-120"/>
+              </a:rPr>
+              <a:t>data/case_evidence.py</a:t>
+            </a:r>
+            <a:endParaRPr lang="en-US" sz="1300" dirty="0"/>
+          </a:p>
+        </p:txBody>
+      </p:sp>
+      <p:sp>
+        <p:nvSpPr>
+          <p:cNvPr id="30" name="Text 28"/>
+          <p:cNvSpPr txBox="1"/>
+          <p:nvPr/>
+        </p:nvSpPr>
+        <p:spPr>
+          <a:xfrm>
+            <a:off x="6647688" y="3575304"/>
+            <a:ext cx="4846320" cy="429768"/>
+          </a:xfrm>
+          <a:prstGeom prst="rect">
+            <a:avLst/>
+          </a:prstGeom>
+          <a:noFill/>
+          <a:ln/>
+        </p:spPr>
+        <p:txBody>
+          <a:bodyPr wrap="square" lIns="0" tIns="0" rIns="0" bIns="0" rtlCol="0" anchor="ctr">
+            <a:normAutofit/>
+          </a:bodyPr>
+          <a:lstStyle/>
+          <a:p>
+            <a:pPr indent="0" marL="0">
+              <a:buNone/>
+            </a:pPr>
+            <a:r>
+              <a:rPr lang="en-US" sz="1200" dirty="0">
+                <a:solidFill>
+                  <a:srgbClr val="C4D6E9"/>
+                </a:solidFill>
+                <a:latin typeface="Arial" pitchFamily="34" charset="0"/>
+                <a:ea typeface="Arial" pitchFamily="34" charset="-122"/>
+                <a:cs typeface="Arial" pitchFamily="34" charset="-120"/>
+              </a:rPr>
+              <a:t>Makes case sources and chunks</a:t>
+            </a:r>
+            <a:endParaRPr lang="en-US" sz="1200" dirty="0"/>
+          </a:p>
+        </p:txBody>
+      </p:sp>
+      <p:sp>
+        <p:nvSpPr>
+          <p:cNvPr id="31" name="Shape 29"/>
+          <p:cNvSpPr/>
+          <p:nvPr/>
+        </p:nvSpPr>
+        <p:spPr>
+          <a:xfrm>
+            <a:off x="685800" y="4197096"/>
+            <a:ext cx="365760" cy="365760"/>
           </a:xfrm>
           <a:prstGeom prst="ellipse">
             <a:avLst/>
           </a:prstGeom>
           <a:solidFill>
+            <a:srgbClr val="2E67B7"/>
+          </a:solidFill>
+          <a:ln w="12700">
+            <a:solidFill>
+              <a:srgbClr val="2E67B7"/>
+            </a:solidFill>
+            <a:prstDash val="solid"/>
+          </a:ln>
+        </p:spPr>
+      </p:sp>
+      <p:sp>
+        <p:nvSpPr>
+          <p:cNvPr id="32" name="Text 30"/>
+          <p:cNvSpPr txBox="1"/>
+          <p:nvPr/>
+        </p:nvSpPr>
+        <p:spPr>
+          <a:xfrm>
+            <a:off x="685800" y="4197096"/>
+            <a:ext cx="365760" cy="365760"/>
+          </a:xfrm>
+          <a:prstGeom prst="rect">
+            <a:avLst/>
+          </a:prstGeom>
+          <a:noFill/>
+          <a:ln/>
+        </p:spPr>
+        <p:txBody>
+          <a:bodyPr wrap="square" lIns="0" tIns="0" rIns="0" bIns="0" rtlCol="0" anchor="ctr">
+            <a:normAutofit/>
+          </a:bodyPr>
+          <a:lstStyle/>
+          <a:p>
+            <a:pPr algn="ctr" indent="0" marL="0">
+              <a:buNone/>
+            </a:pPr>
+            <a:r>
+              <a:rPr lang="en-US" sz="1700" b="1" dirty="0">
+                <a:solidFill>
+                  <a:srgbClr val="FFFFFF"/>
+                </a:solidFill>
+                <a:latin typeface="Arial" pitchFamily="34" charset="0"/>
+                <a:ea typeface="Arial" pitchFamily="34" charset="-122"/>
+                <a:cs typeface="Arial" pitchFamily="34" charset="-120"/>
+              </a:rPr>
+              <a:t>6</a:t>
+            </a:r>
+            <a:endParaRPr lang="en-US" sz="1700" dirty="0"/>
+          </a:p>
+        </p:txBody>
+      </p:sp>
+      <p:sp>
+        <p:nvSpPr>
+          <p:cNvPr id="33" name="Text 31"/>
+          <p:cNvSpPr txBox="1"/>
+          <p:nvPr/>
+        </p:nvSpPr>
+        <p:spPr>
+          <a:xfrm>
+            <a:off x="1261872" y="4133088"/>
+            <a:ext cx="1216152" cy="429768"/>
+          </a:xfrm>
+          <a:prstGeom prst="rect">
+            <a:avLst/>
+          </a:prstGeom>
+          <a:noFill/>
+          <a:ln/>
+        </p:spPr>
+        <p:txBody>
+          <a:bodyPr wrap="square" lIns="0" tIns="0" rIns="0" bIns="0" rtlCol="0" anchor="ctr">
+            <a:normAutofit/>
+          </a:bodyPr>
+          <a:lstStyle/>
+          <a:p>
+            <a:pPr indent="0" marL="0">
+              <a:buNone/>
+            </a:pPr>
+            <a:r>
+              <a:rPr lang="en-US" sz="1300" b="1" dirty="0">
+                <a:solidFill>
+                  <a:srgbClr val="9FE4E5"/>
+                </a:solidFill>
+                <a:latin typeface="Arial" pitchFamily="34" charset="0"/>
+                <a:ea typeface="Arial" pitchFamily="34" charset="-122"/>
+                <a:cs typeface="Arial" pitchFamily="34" charset="-120"/>
+              </a:rPr>
+              <a:t>DRAFT</a:t>
+            </a:r>
+            <a:endParaRPr lang="en-US" sz="1300" dirty="0"/>
+          </a:p>
+        </p:txBody>
+      </p:sp>
+      <p:sp>
+        <p:nvSpPr>
+          <p:cNvPr id="34" name="Text 32"/>
+          <p:cNvSpPr txBox="1"/>
+          <p:nvPr/>
+        </p:nvSpPr>
+        <p:spPr>
+          <a:xfrm>
+            <a:off x="2532888" y="4133088"/>
+            <a:ext cx="4078224" cy="429768"/>
+          </a:xfrm>
+          <a:prstGeom prst="rect">
+            <a:avLst/>
+          </a:prstGeom>
+          <a:noFill/>
+          <a:ln/>
+        </p:spPr>
+        <p:txBody>
+          <a:bodyPr wrap="square" lIns="0" tIns="0" rIns="0" bIns="0" rtlCol="0" anchor="ctr">
+            <a:normAutofit/>
+          </a:bodyPr>
+          <a:lstStyle/>
+          <a:p>
+            <a:pPr indent="0" marL="0">
+              <a:buNone/>
+            </a:pPr>
+            <a:r>
+              <a:rPr lang="en-US" sz="1300" b="1" dirty="0">
+                <a:solidFill>
+                  <a:srgbClr val="FFFFFF"/>
+                </a:solidFill>
+                <a:latin typeface="Arial" pitchFamily="34" charset="0"/>
+                <a:ea typeface="Arial" pitchFamily="34" charset="-122"/>
+                <a:cs typeface="Arial" pitchFamily="34" charset="-120"/>
+              </a:rPr>
+              <a:t>agents/calculated_summary.py</a:t>
+            </a:r>
+            <a:endParaRPr lang="en-US" sz="1300" dirty="0"/>
+          </a:p>
+        </p:txBody>
+      </p:sp>
+      <p:sp>
+        <p:nvSpPr>
+          <p:cNvPr id="35" name="Text 33"/>
+          <p:cNvSpPr txBox="1"/>
+          <p:nvPr/>
+        </p:nvSpPr>
+        <p:spPr>
+          <a:xfrm>
+            <a:off x="6647688" y="4133088"/>
+            <a:ext cx="4846320" cy="429768"/>
+          </a:xfrm>
+          <a:prstGeom prst="rect">
+            <a:avLst/>
+          </a:prstGeom>
+          <a:noFill/>
+          <a:ln/>
+        </p:spPr>
+        <p:txBody>
+          <a:bodyPr wrap="square" lIns="0" tIns="0" rIns="0" bIns="0" rtlCol="0" anchor="ctr">
+            <a:normAutofit/>
+          </a:bodyPr>
+          <a:lstStyle/>
+          <a:p>
+            <a:pPr indent="0" marL="0">
+              <a:buNone/>
+            </a:pPr>
+            <a:r>
+              <a:rPr lang="en-US" sz="1200" dirty="0">
+                <a:solidFill>
+                  <a:srgbClr val="C4D6E9"/>
+                </a:solidFill>
+                <a:latin typeface="Arial" pitchFamily="34" charset="0"/>
+                <a:ea typeface="Arial" pitchFamily="34" charset="-122"/>
+                <a:cs typeface="Arial" pitchFamily="34" charset="-120"/>
+              </a:rPr>
+              <a:t>Builds model-free source draft</a:t>
+            </a:r>
+            <a:endParaRPr lang="en-US" sz="1200" dirty="0"/>
+          </a:p>
+        </p:txBody>
+      </p:sp>
+      <p:sp>
+        <p:nvSpPr>
+          <p:cNvPr id="36" name="Shape 34"/>
+          <p:cNvSpPr/>
+          <p:nvPr/>
+        </p:nvSpPr>
+        <p:spPr>
+          <a:xfrm>
+            <a:off x="685800" y="4754880"/>
+            <a:ext cx="365760" cy="365760"/>
+          </a:xfrm>
+          <a:prstGeom prst="ellipse">
+            <a:avLst/>
+          </a:prstGeom>
+          <a:solidFill>
             <a:srgbClr val="087E8B"/>
           </a:solidFill>
           <a:ln w="12700">
@@ -12892,14 +13689,14 @@
       </p:sp>
       <p:sp>
         <p:nvSpPr>
-          <p:cNvPr id="17" name="Text 15"/>
-          <p:cNvSpPr txBox="1"/>
-          <p:nvPr/>
-        </p:nvSpPr>
-        <p:spPr>
-          <a:xfrm>
-            <a:off x="685800" y="2697480"/>
-            <a:ext cx="384048" cy="384048"/>
+          <p:cNvPr id="37" name="Text 35"/>
+          <p:cNvSpPr txBox="1"/>
+          <p:nvPr/>
+        </p:nvSpPr>
+        <p:spPr>
+          <a:xfrm>
+            <a:off x="685800" y="4754880"/>
+            <a:ext cx="365760" cy="365760"/>
           </a:xfrm>
           <a:prstGeom prst="rect">
             <a:avLst/>
@@ -12925,7 +13722,7 @@
                 <a:ea typeface="Arial" pitchFamily="34" charset="-122"/>
                 <a:cs typeface="Arial" pitchFamily="34" charset="-120"/>
               </a:rPr>
-              <a:t>3</a:t>
+              <a:t>7</a:t>
             </a:r>
             <a:endParaRPr lang="en-US" sz="1700" dirty="0"/>
           </a:p>
@@ -12933,14 +13730,14 @@
       </p:sp>
       <p:sp>
         <p:nvSpPr>
-          <p:cNvPr id="18" name="Text 16"/>
-          <p:cNvSpPr txBox="1"/>
-          <p:nvPr/>
-        </p:nvSpPr>
-        <p:spPr>
-          <a:xfrm>
-            <a:off x="1261872" y="2633472"/>
-            <a:ext cx="1216152" cy="457200"/>
+          <p:cNvPr id="38" name="Text 36"/>
+          <p:cNvSpPr txBox="1"/>
+          <p:nvPr/>
+        </p:nvSpPr>
+        <p:spPr>
+          <a:xfrm>
+            <a:off x="1261872" y="4690872"/>
+            <a:ext cx="1216152" cy="429768"/>
           </a:xfrm>
           <a:prstGeom prst="rect">
             <a:avLst/>
@@ -12958,7 +13755,7 @@
               <a:buNone/>
             </a:pPr>
             <a:r>
-              <a:rPr lang="en-US" sz="1400" b="1" dirty="0">
+              <a:rPr lang="en-US" sz="1300" b="1" dirty="0">
                 <a:solidFill>
                   <a:srgbClr val="9FE4E5"/>
                 </a:solidFill>
@@ -12966,22 +13763,22 @@
                 <a:ea typeface="Arial" pitchFamily="34" charset="-122"/>
                 <a:cs typeface="Arial" pitchFamily="34" charset="-120"/>
               </a:rPr>
-              <a:t>FLOW</a:t>
-            </a:r>
-            <a:endParaRPr lang="en-US" sz="1400" dirty="0"/>
-          </a:p>
-        </p:txBody>
-      </p:sp>
-      <p:sp>
-        <p:nvSpPr>
-          <p:cNvPr id="19" name="Text 17"/>
-          <p:cNvSpPr txBox="1"/>
-          <p:nvPr/>
-        </p:nvSpPr>
-        <p:spPr>
-          <a:xfrm>
-            <a:off x="2532888" y="2633472"/>
-            <a:ext cx="4078224" cy="457200"/>
+              <a:t>CHECK</a:t>
+            </a:r>
+            <a:endParaRPr lang="en-US" sz="1300" dirty="0"/>
+          </a:p>
+        </p:txBody>
+      </p:sp>
+      <p:sp>
+        <p:nvSpPr>
+          <p:cNvPr id="39" name="Text 37"/>
+          <p:cNvSpPr txBox="1"/>
+          <p:nvPr/>
+        </p:nvSpPr>
+        <p:spPr>
+          <a:xfrm>
+            <a:off x="2532888" y="4690872"/>
+            <a:ext cx="4078224" cy="429768"/>
           </a:xfrm>
           <a:prstGeom prst="rect">
             <a:avLst/>
@@ -12999,7 +13796,7 @@
               <a:buNone/>
             </a:pPr>
             <a:r>
-              <a:rPr lang="en-US" sz="1400" b="1" dirty="0">
+              <a:rPr lang="en-US" sz="1300" b="1" dirty="0">
                 <a:solidFill>
                   <a:srgbClr val="FFFFFF"/>
                 </a:solidFill>
@@ -13007,22 +13804,22 @@
                 <a:ea typeface="Arial" pitchFamily="34" charset="-122"/>
                 <a:cs typeface="Arial" pitchFamily="34" charset="-120"/>
               </a:rPr>
-              <a:t>agents/orchestrator.py</a:t>
-            </a:r>
-            <a:endParaRPr lang="en-US" sz="1400" dirty="0"/>
-          </a:p>
-        </p:txBody>
-      </p:sp>
-      <p:sp>
-        <p:nvSpPr>
-          <p:cNvPr id="20" name="Text 18"/>
-          <p:cNvSpPr txBox="1"/>
-          <p:nvPr/>
-        </p:nvSpPr>
-        <p:spPr>
-          <a:xfrm>
-            <a:off x="6647688" y="2633472"/>
-            <a:ext cx="4846320" cy="457200"/>
+              <a:t>agents/grounding_validator.py</a:t>
+            </a:r>
+            <a:endParaRPr lang="en-US" sz="1300" dirty="0"/>
+          </a:p>
+        </p:txBody>
+      </p:sp>
+      <p:sp>
+        <p:nvSpPr>
+          <p:cNvPr id="40" name="Text 38"/>
+          <p:cNvSpPr txBox="1"/>
+          <p:nvPr/>
+        </p:nvSpPr>
+        <p:spPr>
+          <a:xfrm>
+            <a:off x="6647688" y="4690872"/>
+            <a:ext cx="4846320" cy="429768"/>
           </a:xfrm>
           <a:prstGeom prst="rect">
             <a:avLst/>
@@ -13040,7 +13837,7 @@
               <a:buNone/>
             </a:pPr>
             <a:r>
-              <a:rPr lang="en-US" sz="1300" dirty="0">
+              <a:rPr lang="en-US" sz="1200" dirty="0">
                 <a:solidFill>
                   <a:srgbClr val="C4D6E9"/>
                 </a:solidFill>
@@ -13048,7 +13845,114 @@
                 <a:ea typeface="Arial" pitchFamily="34" charset="-122"/>
                 <a:cs typeface="Arial" pitchFamily="34" charset="-120"/>
               </a:rPr>
-              <a:t>Runs six fixed stages</a:t>
+              <a:t>Checks selected claims and IDs</a:t>
+            </a:r>
+            <a:endParaRPr lang="en-US" sz="1200" dirty="0"/>
+          </a:p>
+        </p:txBody>
+      </p:sp>
+      <p:sp>
+        <p:nvSpPr>
+          <p:cNvPr id="41" name="Shape 39"/>
+          <p:cNvSpPr/>
+          <p:nvPr/>
+        </p:nvSpPr>
+        <p:spPr>
+          <a:xfrm>
+            <a:off x="685800" y="5312664"/>
+            <a:ext cx="365760" cy="365760"/>
+          </a:xfrm>
+          <a:prstGeom prst="ellipse">
+            <a:avLst/>
+          </a:prstGeom>
+          <a:solidFill>
+            <a:srgbClr val="2E67B7"/>
+          </a:solidFill>
+          <a:ln w="12700">
+            <a:solidFill>
+              <a:srgbClr val="2E67B7"/>
+            </a:solidFill>
+            <a:prstDash val="solid"/>
+          </a:ln>
+        </p:spPr>
+      </p:sp>
+      <p:sp>
+        <p:nvSpPr>
+          <p:cNvPr id="42" name="Text 40"/>
+          <p:cNvSpPr txBox="1"/>
+          <p:nvPr/>
+        </p:nvSpPr>
+        <p:spPr>
+          <a:xfrm>
+            <a:off x="685800" y="5312664"/>
+            <a:ext cx="365760" cy="365760"/>
+          </a:xfrm>
+          <a:prstGeom prst="rect">
+            <a:avLst/>
+          </a:prstGeom>
+          <a:noFill/>
+          <a:ln/>
+        </p:spPr>
+        <p:txBody>
+          <a:bodyPr wrap="square" lIns="0" tIns="0" rIns="0" bIns="0" rtlCol="0" anchor="ctr">
+            <a:normAutofit/>
+          </a:bodyPr>
+          <a:lstStyle/>
+          <a:p>
+            <a:pPr algn="ctr" indent="0" marL="0">
+              <a:buNone/>
+            </a:pPr>
+            <a:r>
+              <a:rPr lang="en-US" sz="1700" b="1" dirty="0">
+                <a:solidFill>
+                  <a:srgbClr val="FFFFFF"/>
+                </a:solidFill>
+                <a:latin typeface="Arial" pitchFamily="34" charset="0"/>
+                <a:ea typeface="Arial" pitchFamily="34" charset="-122"/>
+                <a:cs typeface="Arial" pitchFamily="34" charset="-120"/>
+              </a:rPr>
+              <a:t>8</a:t>
+            </a:r>
+            <a:endParaRPr lang="en-US" sz="1700" dirty="0"/>
+          </a:p>
+        </p:txBody>
+      </p:sp>
+      <p:sp>
+        <p:nvSpPr>
+          <p:cNvPr id="43" name="Text 41"/>
+          <p:cNvSpPr txBox="1"/>
+          <p:nvPr/>
+        </p:nvSpPr>
+        <p:spPr>
+          <a:xfrm>
+            <a:off x="1261872" y="5248656"/>
+            <a:ext cx="1216152" cy="429768"/>
+          </a:xfrm>
+          <a:prstGeom prst="rect">
+            <a:avLst/>
+          </a:prstGeom>
+          <a:noFill/>
+          <a:ln/>
+        </p:spPr>
+        <p:txBody>
+          <a:bodyPr wrap="square" lIns="0" tIns="0" rIns="0" bIns="0" rtlCol="0" anchor="ctr">
+            <a:normAutofit/>
+          </a:bodyPr>
+          <a:lstStyle/>
+          <a:p>
+            <a:pPr indent="0" marL="0">
+              <a:buNone/>
+            </a:pPr>
+            <a:r>
+              <a:rPr lang="en-US" sz="1300" b="1" dirty="0">
+                <a:solidFill>
+                  <a:srgbClr val="9FE4E5"/>
+                </a:solidFill>
+                <a:latin typeface="Arial" pitchFamily="34" charset="0"/>
+                <a:ea typeface="Arial" pitchFamily="34" charset="-122"/>
+                <a:cs typeface="Arial" pitchFamily="34" charset="-120"/>
+              </a:rPr>
+              <a:t>DECIDE</a:t>
             </a:r>
             <a:endParaRPr lang="en-US" sz="1300" dirty="0"/>
           </a:p>
@@ -13056,57 +13960,32 @@
       </p:sp>
       <p:sp>
         <p:nvSpPr>
-          <p:cNvPr id="21" name="Shape 19"/>
-          <p:cNvSpPr/>
-          <p:nvPr/>
-        </p:nvSpPr>
-        <p:spPr>
-          <a:xfrm>
-            <a:off x="685800" y="3328416"/>
-            <a:ext cx="384048" cy="384048"/>
-          </a:xfrm>
-          <a:prstGeom prst="ellipse">
-            <a:avLst/>
-          </a:prstGeom>
-          <a:solidFill>
-            <a:srgbClr val="2E67B7"/>
-          </a:solidFill>
-          <a:ln w="12700">
-            <a:solidFill>
-              <a:srgbClr val="2E67B7"/>
-            </a:solidFill>
-            <a:prstDash val="solid"/>
-          </a:ln>
-        </p:spPr>
-      </p:sp>
-      <p:sp>
-        <p:nvSpPr>
-          <p:cNvPr id="22" name="Text 20"/>
-          <p:cNvSpPr txBox="1"/>
-          <p:nvPr/>
-        </p:nvSpPr>
-        <p:spPr>
-          <a:xfrm>
-            <a:off x="685800" y="3328416"/>
-            <a:ext cx="384048" cy="384048"/>
-          </a:xfrm>
-          <a:prstGeom prst="rect">
-            <a:avLst/>
-          </a:prstGeom>
-          <a:noFill/>
-          <a:ln/>
-        </p:spPr>
-        <p:txBody>
-          <a:bodyPr wrap="square" lIns="0" tIns="0" rIns="0" bIns="0" rtlCol="0" anchor="ctr">
-            <a:normAutofit/>
-          </a:bodyPr>
-          <a:lstStyle/>
-          <a:p>
-            <a:pPr algn="ctr" indent="0" marL="0">
-              <a:buNone/>
-            </a:pPr>
-            <a:r>
-              <a:rPr lang="en-US" sz="1700" b="1" dirty="0">
+          <p:cNvPr id="44" name="Text 42"/>
+          <p:cNvSpPr txBox="1"/>
+          <p:nvPr/>
+        </p:nvSpPr>
+        <p:spPr>
+          <a:xfrm>
+            <a:off x="2532888" y="5248656"/>
+            <a:ext cx="4078224" cy="429768"/>
+          </a:xfrm>
+          <a:prstGeom prst="rect">
+            <a:avLst/>
+          </a:prstGeom>
+          <a:noFill/>
+          <a:ln/>
+        </p:spPr>
+        <p:txBody>
+          <a:bodyPr wrap="square" lIns="0" tIns="0" rIns="0" bIns="0" rtlCol="0" anchor="ctr">
+            <a:normAutofit/>
+          </a:bodyPr>
+          <a:lstStyle/>
+          <a:p>
+            <a:pPr indent="0" marL="0">
+              <a:buNone/>
+            </a:pPr>
+            <a:r>
+              <a:rPr lang="en-US" sz="1300" b="1" dirty="0">
                 <a:solidFill>
                   <a:srgbClr val="FFFFFF"/>
                 </a:solidFill>
@@ -13114,22 +13993,22 @@
                 <a:ea typeface="Arial" pitchFamily="34" charset="-122"/>
                 <a:cs typeface="Arial" pitchFamily="34" charset="-120"/>
               </a:rPr>
-              <a:t>4</a:t>
-            </a:r>
-            <a:endParaRPr lang="en-US" sz="1700" dirty="0"/>
-          </a:p>
-        </p:txBody>
-      </p:sp>
-      <p:sp>
-        <p:nvSpPr>
-          <p:cNvPr id="23" name="Text 21"/>
-          <p:cNvSpPr txBox="1"/>
-          <p:nvPr/>
-        </p:nvSpPr>
-        <p:spPr>
-          <a:xfrm>
-            <a:off x="1261872" y="3264408"/>
-            <a:ext cx="1216152" cy="457200"/>
+              <a:t>data/runtime_db.py</a:t>
+            </a:r>
+            <a:endParaRPr lang="en-US" sz="1300" dirty="0"/>
+          </a:p>
+        </p:txBody>
+      </p:sp>
+      <p:sp>
+        <p:nvSpPr>
+          <p:cNvPr id="45" name="Text 43"/>
+          <p:cNvSpPr txBox="1"/>
+          <p:nvPr/>
+        </p:nvSpPr>
+        <p:spPr>
+          <a:xfrm>
+            <a:off x="6647688" y="5248656"/>
+            <a:ext cx="4846320" cy="429768"/>
           </a:xfrm>
           <a:prstGeom prst="rect">
             <a:avLst/>
@@ -13147,89 +14026,7 @@
               <a:buNone/>
             </a:pPr>
             <a:r>
-              <a:rPr lang="en-US" sz="1400" b="1" dirty="0">
-                <a:solidFill>
-                  <a:srgbClr val="9FE4E5"/>
-                </a:solidFill>
-                <a:latin typeface="Arial" pitchFamily="34" charset="0"/>
-                <a:ea typeface="Arial" pitchFamily="34" charset="-122"/>
-                <a:cs typeface="Arial" pitchFamily="34" charset="-120"/>
-              </a:rPr>
-              <a:t>RAG</a:t>
-            </a:r>
-            <a:endParaRPr lang="en-US" sz="1400" dirty="0"/>
-          </a:p>
-        </p:txBody>
-      </p:sp>
-      <p:sp>
-        <p:nvSpPr>
-          <p:cNvPr id="24" name="Text 22"/>
-          <p:cNvSpPr txBox="1"/>
-          <p:nvPr/>
-        </p:nvSpPr>
-        <p:spPr>
-          <a:xfrm>
-            <a:off x="2532888" y="3264408"/>
-            <a:ext cx="4078224" cy="457200"/>
-          </a:xfrm>
-          <a:prstGeom prst="rect">
-            <a:avLst/>
-          </a:prstGeom>
-          <a:noFill/>
-          <a:ln/>
-        </p:spPr>
-        <p:txBody>
-          <a:bodyPr wrap="square" lIns="0" tIns="0" rIns="0" bIns="0" rtlCol="0" anchor="ctr">
-            <a:normAutofit/>
-          </a:bodyPr>
-          <a:lstStyle/>
-          <a:p>
-            <a:pPr indent="0" marL="0">
-              <a:buNone/>
-            </a:pPr>
-            <a:r>
-              <a:rPr lang="en-US" sz="1400" b="1" dirty="0">
-                <a:solidFill>
-                  <a:srgbClr val="FFFFFF"/>
-                </a:solidFill>
-                <a:latin typeface="Arial" pitchFamily="34" charset="0"/>
-                <a:ea typeface="Arial" pitchFamily="34" charset="-122"/>
-                <a:cs typeface="Arial" pitchFamily="34" charset="-120"/>
-              </a:rPr>
-              <a:t>data/case_evidence.py</a:t>
-            </a:r>
-            <a:endParaRPr lang="en-US" sz="1400" dirty="0"/>
-          </a:p>
-        </p:txBody>
-      </p:sp>
-      <p:sp>
-        <p:nvSpPr>
-          <p:cNvPr id="25" name="Text 23"/>
-          <p:cNvSpPr txBox="1"/>
-          <p:nvPr/>
-        </p:nvSpPr>
-        <p:spPr>
-          <a:xfrm>
-            <a:off x="6647688" y="3264408"/>
-            <a:ext cx="4846320" cy="457200"/>
-          </a:xfrm>
-          <a:prstGeom prst="rect">
-            <a:avLst/>
-          </a:prstGeom>
-          <a:noFill/>
-          <a:ln/>
-        </p:spPr>
-        <p:txBody>
-          <a:bodyPr wrap="square" lIns="0" tIns="0" rIns="0" bIns="0" rtlCol="0" anchor="ctr">
-            <a:normAutofit/>
-          </a:bodyPr>
-          <a:lstStyle/>
-          <a:p>
-            <a:pPr indent="0" marL="0">
-              <a:buNone/>
-            </a:pPr>
-            <a:r>
-              <a:rPr lang="en-US" sz="1300" dirty="0">
+              <a:rPr lang="en-US" sz="1200" dirty="0">
                 <a:solidFill>
                   <a:srgbClr val="C4D6E9"/>
                 </a:solidFill>
@@ -13237,582 +14034,15 @@
                 <a:ea typeface="Arial" pitchFamily="34" charset="-122"/>
                 <a:cs typeface="Arial" pitchFamily="34" charset="-120"/>
               </a:rPr>
-              <a:t>Makes case sources and chunks</a:t>
-            </a:r>
-            <a:endParaRPr lang="en-US" sz="1300" dirty="0"/>
-          </a:p>
-        </p:txBody>
-      </p:sp>
-      <p:sp>
-        <p:nvSpPr>
-          <p:cNvPr id="26" name="Shape 24"/>
-          <p:cNvSpPr/>
-          <p:nvPr/>
-        </p:nvSpPr>
-        <p:spPr>
-          <a:xfrm>
-            <a:off x="685800" y="3959352"/>
-            <a:ext cx="384048" cy="384048"/>
-          </a:xfrm>
-          <a:prstGeom prst="ellipse">
-            <a:avLst/>
-          </a:prstGeom>
-          <a:solidFill>
-            <a:srgbClr val="087E8B"/>
-          </a:solidFill>
-          <a:ln w="12700">
-            <a:solidFill>
-              <a:srgbClr val="087E8B"/>
-            </a:solidFill>
-            <a:prstDash val="solid"/>
-          </a:ln>
-        </p:spPr>
-      </p:sp>
-      <p:sp>
-        <p:nvSpPr>
-          <p:cNvPr id="27" name="Text 25"/>
-          <p:cNvSpPr txBox="1"/>
-          <p:nvPr/>
-        </p:nvSpPr>
-        <p:spPr>
-          <a:xfrm>
-            <a:off x="685800" y="3959352"/>
-            <a:ext cx="384048" cy="384048"/>
-          </a:xfrm>
-          <a:prstGeom prst="rect">
-            <a:avLst/>
-          </a:prstGeom>
-          <a:noFill/>
-          <a:ln/>
-        </p:spPr>
-        <p:txBody>
-          <a:bodyPr wrap="square" lIns="0" tIns="0" rIns="0" bIns="0" rtlCol="0" anchor="ctr">
-            <a:normAutofit/>
-          </a:bodyPr>
-          <a:lstStyle/>
-          <a:p>
-            <a:pPr algn="ctr" indent="0" marL="0">
-              <a:buNone/>
-            </a:pPr>
-            <a:r>
-              <a:rPr lang="en-US" sz="1700" b="1" dirty="0">
-                <a:solidFill>
-                  <a:srgbClr val="FFFFFF"/>
-                </a:solidFill>
-                <a:latin typeface="Arial" pitchFamily="34" charset="0"/>
-                <a:ea typeface="Arial" pitchFamily="34" charset="-122"/>
-                <a:cs typeface="Arial" pitchFamily="34" charset="-120"/>
-              </a:rPr>
-              <a:t>5</a:t>
-            </a:r>
-            <a:endParaRPr lang="en-US" sz="1700" dirty="0"/>
-          </a:p>
-        </p:txBody>
-      </p:sp>
-      <p:sp>
-        <p:nvSpPr>
-          <p:cNvPr id="28" name="Text 26"/>
-          <p:cNvSpPr txBox="1"/>
-          <p:nvPr/>
-        </p:nvSpPr>
-        <p:spPr>
-          <a:xfrm>
-            <a:off x="1261872" y="3895344"/>
-            <a:ext cx="1216152" cy="457200"/>
-          </a:xfrm>
-          <a:prstGeom prst="rect">
-            <a:avLst/>
-          </a:prstGeom>
-          <a:noFill/>
-          <a:ln/>
-        </p:spPr>
-        <p:txBody>
-          <a:bodyPr wrap="square" lIns="0" tIns="0" rIns="0" bIns="0" rtlCol="0" anchor="ctr">
-            <a:normAutofit/>
-          </a:bodyPr>
-          <a:lstStyle/>
-          <a:p>
-            <a:pPr indent="0" marL="0">
-              <a:buNone/>
-            </a:pPr>
-            <a:r>
-              <a:rPr lang="en-US" sz="1400" b="1" dirty="0">
-                <a:solidFill>
-                  <a:srgbClr val="9FE4E5"/>
-                </a:solidFill>
-                <a:latin typeface="Arial" pitchFamily="34" charset="0"/>
-                <a:ea typeface="Arial" pitchFamily="34" charset="-122"/>
-                <a:cs typeface="Arial" pitchFamily="34" charset="-120"/>
-              </a:rPr>
-              <a:t>DRAFT</a:t>
-            </a:r>
-            <a:endParaRPr lang="en-US" sz="1400" dirty="0"/>
-          </a:p>
-        </p:txBody>
-      </p:sp>
-      <p:sp>
-        <p:nvSpPr>
-          <p:cNvPr id="29" name="Text 27"/>
-          <p:cNvSpPr txBox="1"/>
-          <p:nvPr/>
-        </p:nvSpPr>
-        <p:spPr>
-          <a:xfrm>
-            <a:off x="2532888" y="3895344"/>
-            <a:ext cx="4078224" cy="457200"/>
-          </a:xfrm>
-          <a:prstGeom prst="rect">
-            <a:avLst/>
-          </a:prstGeom>
-          <a:noFill/>
-          <a:ln/>
-        </p:spPr>
-        <p:txBody>
-          <a:bodyPr wrap="square" lIns="0" tIns="0" rIns="0" bIns="0" rtlCol="0" anchor="ctr">
-            <a:normAutofit/>
-          </a:bodyPr>
-          <a:lstStyle/>
-          <a:p>
-            <a:pPr indent="0" marL="0">
-              <a:buNone/>
-            </a:pPr>
-            <a:r>
-              <a:rPr lang="en-US" sz="1400" b="1" dirty="0">
-                <a:solidFill>
-                  <a:srgbClr val="FFFFFF"/>
-                </a:solidFill>
-                <a:latin typeface="Arial" pitchFamily="34" charset="0"/>
-                <a:ea typeface="Arial" pitchFamily="34" charset="-122"/>
-                <a:cs typeface="Arial" pitchFamily="34" charset="-120"/>
-              </a:rPr>
-              <a:t>agents/calculated_summary.py</a:t>
-            </a:r>
-            <a:endParaRPr lang="en-US" sz="1400" dirty="0"/>
-          </a:p>
-        </p:txBody>
-      </p:sp>
-      <p:sp>
-        <p:nvSpPr>
-          <p:cNvPr id="30" name="Text 28"/>
-          <p:cNvSpPr txBox="1"/>
-          <p:nvPr/>
-        </p:nvSpPr>
-        <p:spPr>
-          <a:xfrm>
-            <a:off x="6647688" y="3895344"/>
-            <a:ext cx="4846320" cy="457200"/>
-          </a:xfrm>
-          <a:prstGeom prst="rect">
-            <a:avLst/>
-          </a:prstGeom>
-          <a:noFill/>
-          <a:ln/>
-        </p:spPr>
-        <p:txBody>
-          <a:bodyPr wrap="square" lIns="0" tIns="0" rIns="0" bIns="0" rtlCol="0" anchor="ctr">
-            <a:normAutofit/>
-          </a:bodyPr>
-          <a:lstStyle/>
-          <a:p>
-            <a:pPr indent="0" marL="0">
-              <a:buNone/>
-            </a:pPr>
-            <a:r>
-              <a:rPr lang="en-US" sz="1300" dirty="0">
-                <a:solidFill>
-                  <a:srgbClr val="C4D6E9"/>
-                </a:solidFill>
-                <a:latin typeface="Arial" pitchFamily="34" charset="0"/>
-                <a:ea typeface="Arial" pitchFamily="34" charset="-122"/>
-                <a:cs typeface="Arial" pitchFamily="34" charset="-120"/>
-              </a:rPr>
-              <a:t>Builds model-free source draft</a:t>
-            </a:r>
-            <a:endParaRPr lang="en-US" sz="1300" dirty="0"/>
-          </a:p>
-        </p:txBody>
-      </p:sp>
-      <p:sp>
-        <p:nvSpPr>
-          <p:cNvPr id="31" name="Shape 29"/>
-          <p:cNvSpPr/>
-          <p:nvPr/>
-        </p:nvSpPr>
-        <p:spPr>
-          <a:xfrm>
-            <a:off x="685800" y="4590288"/>
-            <a:ext cx="384048" cy="384048"/>
-          </a:xfrm>
-          <a:prstGeom prst="ellipse">
-            <a:avLst/>
-          </a:prstGeom>
-          <a:solidFill>
-            <a:srgbClr val="2E67B7"/>
-          </a:solidFill>
-          <a:ln w="12700">
-            <a:solidFill>
-              <a:srgbClr val="2E67B7"/>
-            </a:solidFill>
-            <a:prstDash val="solid"/>
-          </a:ln>
-        </p:spPr>
-      </p:sp>
-      <p:sp>
-        <p:nvSpPr>
-          <p:cNvPr id="32" name="Text 30"/>
-          <p:cNvSpPr txBox="1"/>
-          <p:nvPr/>
-        </p:nvSpPr>
-        <p:spPr>
-          <a:xfrm>
-            <a:off x="685800" y="4590288"/>
-            <a:ext cx="384048" cy="384048"/>
-          </a:xfrm>
-          <a:prstGeom prst="rect">
-            <a:avLst/>
-          </a:prstGeom>
-          <a:noFill/>
-          <a:ln/>
-        </p:spPr>
-        <p:txBody>
-          <a:bodyPr wrap="square" lIns="0" tIns="0" rIns="0" bIns="0" rtlCol="0" anchor="ctr">
-            <a:normAutofit/>
-          </a:bodyPr>
-          <a:lstStyle/>
-          <a:p>
-            <a:pPr algn="ctr" indent="0" marL="0">
-              <a:buNone/>
-            </a:pPr>
-            <a:r>
-              <a:rPr lang="en-US" sz="1700" b="1" dirty="0">
-                <a:solidFill>
-                  <a:srgbClr val="FFFFFF"/>
-                </a:solidFill>
-                <a:latin typeface="Arial" pitchFamily="34" charset="0"/>
-                <a:ea typeface="Arial" pitchFamily="34" charset="-122"/>
-                <a:cs typeface="Arial" pitchFamily="34" charset="-120"/>
-              </a:rPr>
-              <a:t>6</a:t>
-            </a:r>
-            <a:endParaRPr lang="en-US" sz="1700" dirty="0"/>
-          </a:p>
-        </p:txBody>
-      </p:sp>
-      <p:sp>
-        <p:nvSpPr>
-          <p:cNvPr id="33" name="Text 31"/>
-          <p:cNvSpPr txBox="1"/>
-          <p:nvPr/>
-        </p:nvSpPr>
-        <p:spPr>
-          <a:xfrm>
-            <a:off x="1261872" y="4526280"/>
-            <a:ext cx="1216152" cy="457200"/>
-          </a:xfrm>
-          <a:prstGeom prst="rect">
-            <a:avLst/>
-          </a:prstGeom>
-          <a:noFill/>
-          <a:ln/>
-        </p:spPr>
-        <p:txBody>
-          <a:bodyPr wrap="square" lIns="0" tIns="0" rIns="0" bIns="0" rtlCol="0" anchor="ctr">
-            <a:normAutofit/>
-          </a:bodyPr>
-          <a:lstStyle/>
-          <a:p>
-            <a:pPr indent="0" marL="0">
-              <a:buNone/>
-            </a:pPr>
-            <a:r>
-              <a:rPr lang="en-US" sz="1400" b="1" dirty="0">
-                <a:solidFill>
-                  <a:srgbClr val="9FE4E5"/>
-                </a:solidFill>
-                <a:latin typeface="Arial" pitchFamily="34" charset="0"/>
-                <a:ea typeface="Arial" pitchFamily="34" charset="-122"/>
-                <a:cs typeface="Arial" pitchFamily="34" charset="-120"/>
-              </a:rPr>
-              <a:t>CHECK</a:t>
-            </a:r>
-            <a:endParaRPr lang="en-US" sz="1400" dirty="0"/>
-          </a:p>
-        </p:txBody>
-      </p:sp>
-      <p:sp>
-        <p:nvSpPr>
-          <p:cNvPr id="34" name="Text 32"/>
-          <p:cNvSpPr txBox="1"/>
-          <p:nvPr/>
-        </p:nvSpPr>
-        <p:spPr>
-          <a:xfrm>
-            <a:off x="2532888" y="4526280"/>
-            <a:ext cx="4078224" cy="457200"/>
-          </a:xfrm>
-          <a:prstGeom prst="rect">
-            <a:avLst/>
-          </a:prstGeom>
-          <a:noFill/>
-          <a:ln/>
-        </p:spPr>
-        <p:txBody>
-          <a:bodyPr wrap="square" lIns="0" tIns="0" rIns="0" bIns="0" rtlCol="0" anchor="ctr">
-            <a:normAutofit/>
-          </a:bodyPr>
-          <a:lstStyle/>
-          <a:p>
-            <a:pPr indent="0" marL="0">
-              <a:buNone/>
-            </a:pPr>
-            <a:r>
-              <a:rPr lang="en-US" sz="1400" b="1" dirty="0">
-                <a:solidFill>
-                  <a:srgbClr val="FFFFFF"/>
-                </a:solidFill>
-                <a:latin typeface="Arial" pitchFamily="34" charset="0"/>
-                <a:ea typeface="Arial" pitchFamily="34" charset="-122"/>
-                <a:cs typeface="Arial" pitchFamily="34" charset="-120"/>
-              </a:rPr>
-              <a:t>agents/grounding_validator.py</a:t>
-            </a:r>
-            <a:endParaRPr lang="en-US" sz="1400" dirty="0"/>
-          </a:p>
-        </p:txBody>
-      </p:sp>
-      <p:sp>
-        <p:nvSpPr>
-          <p:cNvPr id="35" name="Text 33"/>
-          <p:cNvSpPr txBox="1"/>
-          <p:nvPr/>
-        </p:nvSpPr>
-        <p:spPr>
-          <a:xfrm>
-            <a:off x="6647688" y="4526280"/>
-            <a:ext cx="4846320" cy="457200"/>
-          </a:xfrm>
-          <a:prstGeom prst="rect">
-            <a:avLst/>
-          </a:prstGeom>
-          <a:noFill/>
-          <a:ln/>
-        </p:spPr>
-        <p:txBody>
-          <a:bodyPr wrap="square" lIns="0" tIns="0" rIns="0" bIns="0" rtlCol="0" anchor="ctr">
-            <a:normAutofit/>
-          </a:bodyPr>
-          <a:lstStyle/>
-          <a:p>
-            <a:pPr indent="0" marL="0">
-              <a:buNone/>
-            </a:pPr>
-            <a:r>
-              <a:rPr lang="en-US" sz="1300" dirty="0">
-                <a:solidFill>
-                  <a:srgbClr val="C4D6E9"/>
-                </a:solidFill>
-                <a:latin typeface="Arial" pitchFamily="34" charset="0"/>
-                <a:ea typeface="Arial" pitchFamily="34" charset="-122"/>
-                <a:cs typeface="Arial" pitchFamily="34" charset="-120"/>
-              </a:rPr>
-              <a:t>Checks selected claims and IDs</a:t>
-            </a:r>
-            <a:endParaRPr lang="en-US" sz="1300" dirty="0"/>
-          </a:p>
-        </p:txBody>
-      </p:sp>
-      <p:sp>
-        <p:nvSpPr>
-          <p:cNvPr id="36" name="Shape 34"/>
-          <p:cNvSpPr/>
-          <p:nvPr/>
-        </p:nvSpPr>
-        <p:spPr>
-          <a:xfrm>
-            <a:off x="685800" y="5221224"/>
-            <a:ext cx="384048" cy="384048"/>
-          </a:xfrm>
-          <a:prstGeom prst="ellipse">
-            <a:avLst/>
-          </a:prstGeom>
-          <a:solidFill>
-            <a:srgbClr val="087E8B"/>
-          </a:solidFill>
-          <a:ln w="12700">
-            <a:solidFill>
-              <a:srgbClr val="087E8B"/>
-            </a:solidFill>
-            <a:prstDash val="solid"/>
-          </a:ln>
-        </p:spPr>
-      </p:sp>
-      <p:sp>
-        <p:nvSpPr>
-          <p:cNvPr id="37" name="Text 35"/>
-          <p:cNvSpPr txBox="1"/>
-          <p:nvPr/>
-        </p:nvSpPr>
-        <p:spPr>
-          <a:xfrm>
-            <a:off x="685800" y="5221224"/>
-            <a:ext cx="384048" cy="384048"/>
-          </a:xfrm>
-          <a:prstGeom prst="rect">
-            <a:avLst/>
-          </a:prstGeom>
-          <a:noFill/>
-          <a:ln/>
-        </p:spPr>
-        <p:txBody>
-          <a:bodyPr wrap="square" lIns="0" tIns="0" rIns="0" bIns="0" rtlCol="0" anchor="ctr">
-            <a:normAutofit/>
-          </a:bodyPr>
-          <a:lstStyle/>
-          <a:p>
-            <a:pPr algn="ctr" indent="0" marL="0">
-              <a:buNone/>
-            </a:pPr>
-            <a:r>
-              <a:rPr lang="en-US" sz="1700" b="1" dirty="0">
-                <a:solidFill>
-                  <a:srgbClr val="FFFFFF"/>
-                </a:solidFill>
-                <a:latin typeface="Arial" pitchFamily="34" charset="0"/>
-                <a:ea typeface="Arial" pitchFamily="34" charset="-122"/>
-                <a:cs typeface="Arial" pitchFamily="34" charset="-120"/>
-              </a:rPr>
-              <a:t>7</a:t>
-            </a:r>
-            <a:endParaRPr lang="en-US" sz="1700" dirty="0"/>
-          </a:p>
-        </p:txBody>
-      </p:sp>
-      <p:sp>
-        <p:nvSpPr>
-          <p:cNvPr id="38" name="Text 36"/>
-          <p:cNvSpPr txBox="1"/>
-          <p:nvPr/>
-        </p:nvSpPr>
-        <p:spPr>
-          <a:xfrm>
-            <a:off x="1261872" y="5157216"/>
-            <a:ext cx="1216152" cy="457200"/>
-          </a:xfrm>
-          <a:prstGeom prst="rect">
-            <a:avLst/>
-          </a:prstGeom>
-          <a:noFill/>
-          <a:ln/>
-        </p:spPr>
-        <p:txBody>
-          <a:bodyPr wrap="square" lIns="0" tIns="0" rIns="0" bIns="0" rtlCol="0" anchor="ctr">
-            <a:normAutofit/>
-          </a:bodyPr>
-          <a:lstStyle/>
-          <a:p>
-            <a:pPr indent="0" marL="0">
-              <a:buNone/>
-            </a:pPr>
-            <a:r>
-              <a:rPr lang="en-US" sz="1400" b="1" dirty="0">
-                <a:solidFill>
-                  <a:srgbClr val="9FE4E5"/>
-                </a:solidFill>
-                <a:latin typeface="Arial" pitchFamily="34" charset="0"/>
-                <a:ea typeface="Arial" pitchFamily="34" charset="-122"/>
-                <a:cs typeface="Arial" pitchFamily="34" charset="-120"/>
-              </a:rPr>
-              <a:t>DECIDE</a:t>
-            </a:r>
-            <a:endParaRPr lang="en-US" sz="1400" dirty="0"/>
-          </a:p>
-        </p:txBody>
-      </p:sp>
-      <p:sp>
-        <p:nvSpPr>
-          <p:cNvPr id="39" name="Text 37"/>
-          <p:cNvSpPr txBox="1"/>
-          <p:nvPr/>
-        </p:nvSpPr>
-        <p:spPr>
-          <a:xfrm>
-            <a:off x="2532888" y="5157216"/>
-            <a:ext cx="4078224" cy="457200"/>
-          </a:xfrm>
-          <a:prstGeom prst="rect">
-            <a:avLst/>
-          </a:prstGeom>
-          <a:noFill/>
-          <a:ln/>
-        </p:spPr>
-        <p:txBody>
-          <a:bodyPr wrap="square" lIns="0" tIns="0" rIns="0" bIns="0" rtlCol="0" anchor="ctr">
-            <a:normAutofit/>
-          </a:bodyPr>
-          <a:lstStyle/>
-          <a:p>
-            <a:pPr indent="0" marL="0">
-              <a:buNone/>
-            </a:pPr>
-            <a:r>
-              <a:rPr lang="en-US" sz="1400" b="1" dirty="0">
-                <a:solidFill>
-                  <a:srgbClr val="FFFFFF"/>
-                </a:solidFill>
-                <a:latin typeface="Arial" pitchFamily="34" charset="0"/>
-                <a:ea typeface="Arial" pitchFamily="34" charset="-122"/>
-                <a:cs typeface="Arial" pitchFamily="34" charset="-120"/>
-              </a:rPr>
-              <a:t>data/runtime_db.py</a:t>
-            </a:r>
-            <a:endParaRPr lang="en-US" sz="1400" dirty="0"/>
-          </a:p>
-        </p:txBody>
-      </p:sp>
-      <p:sp>
-        <p:nvSpPr>
-          <p:cNvPr id="40" name="Text 38"/>
-          <p:cNvSpPr txBox="1"/>
-          <p:nvPr/>
-        </p:nvSpPr>
-        <p:spPr>
-          <a:xfrm>
-            <a:off x="6647688" y="5157216"/>
-            <a:ext cx="4846320" cy="457200"/>
-          </a:xfrm>
-          <a:prstGeom prst="rect">
-            <a:avLst/>
-          </a:prstGeom>
-          <a:noFill/>
-          <a:ln/>
-        </p:spPr>
-        <p:txBody>
-          <a:bodyPr wrap="square" lIns="0" tIns="0" rIns="0" bIns="0" rtlCol="0" anchor="ctr">
-            <a:normAutofit/>
-          </a:bodyPr>
-          <a:lstStyle/>
-          <a:p>
-            <a:pPr indent="0" marL="0">
-              <a:buNone/>
-            </a:pPr>
-            <a:r>
-              <a:rPr lang="en-US" sz="1300" dirty="0">
-                <a:solidFill>
-                  <a:srgbClr val="C4D6E9"/>
-                </a:solidFill>
-                <a:latin typeface="Arial" pitchFamily="34" charset="0"/>
-                <a:ea typeface="Arial" pitchFamily="34" charset="-122"/>
-                <a:cs typeface="Arial" pitchFamily="34" charset="-120"/>
-              </a:rPr>
               <a:t>Persists human action and audit</a:t>
             </a:r>
-            <a:endParaRPr lang="en-US" sz="1300" dirty="0"/>
-          </a:p>
-        </p:txBody>
-      </p:sp>
-      <p:sp>
-        <p:nvSpPr>
-          <p:cNvPr id="41" name="Text 39"/>
+            <a:endParaRPr lang="en-US" sz="1200" dirty="0"/>
+          </a:p>
+        </p:txBody>
+      </p:sp>
+      <p:sp>
+        <p:nvSpPr>
+          <p:cNvPr id="46" name="Text 44"/>
           <p:cNvSpPr txBox="1"/>
           <p:nvPr/>
         </p:nvSpPr>
@@ -15548,7 +15778,7 @@
                 <a:ea typeface="Arial" pitchFamily="34" charset="-122"/>
                 <a:cs typeface="Arial" pitchFamily="34" charset="-120"/>
               </a:rPr>
-              <a:t>Six fixed stages</a:t>
+              <a:t>Six stages or intake packet</a:t>
             </a:r>
             <a:endParaRPr lang="en-US" sz="1200" dirty="0"/>
           </a:p>
@@ -17415,7 +17645,7 @@
                 <a:ea typeface="Arial" pitchFamily="34" charset="-122"/>
                 <a:cs typeface="Arial" pitchFamily="34" charset="-120"/>
               </a:rPr>
-              <a:t>42 workbook alerts plus two matched ten-transaction case fixtures.</a:t>
+              <a:t>42 workbook alerts, two matched fixtures, and optional numeric-only intake.</a:t>
             </a:r>
             <a:endParaRPr lang="en-US" sz="1300" dirty="0"/>
           </a:p>
@@ -17590,7 +17820,7 @@
                 <a:ea typeface="Arial" pitchFamily="34" charset="-122"/>
                 <a:cs typeface="Arial" pitchFamily="34" charset="-120"/>
               </a:rPr>
-              <a:t>data/incoming_monitor.py tests the new batches; the database build stores two calculated alerts.</a:t>
+              <a:t>The rule calculates signals; enabled intake stores synthetic rows and labeled chunks separately.</a:t>
             </a:r>
             <a:endParaRPr lang="en-US" sz="1300" dirty="0"/>
           </a:p>
@@ -17765,7 +17995,7 @@
                 <a:ea typeface="Arial" pitchFamily="34" charset="-122"/>
                 <a:cs typeface="Arial" pitchFamily="34" charset="-120"/>
               </a:rPr>
-              <a:t>pages/0_Case_Queue.py reads the 44 alert rows and opens a selected case.</a:t>
+              <a:t>44 source alerts plus feature-gated new fictional cases open their matching review path.</a:t>
             </a:r>
             <a:endParaRPr lang="en-US" sz="1300" dirty="0"/>
           </a:p>
@@ -19121,7 +19351,7 @@
         <p:spPr>
           <a:xfrm>
             <a:off x="6839712" y="2880360"/>
-            <a:ext cx="4206240" cy="1197864"/>
+            <a:ext cx="4206240" cy="1325880"/>
           </a:xfrm>
           <a:prstGeom prst="rect">
             <a:avLst/>
@@ -19139,7 +19369,7 @@
               <a:buNone/>
             </a:pPr>
             <a:r>
-              <a:rPr lang="en-US" sz="1600" dirty="0">
+              <a:rPr lang="en-US" sz="1500" dirty="0">
                 <a:solidFill>
                   <a:srgbClr val="172840"/>
                 </a:solidFill>
@@ -19147,9 +19377,9 @@
                 <a:ea typeface="Arial" pitchFamily="34" charset="-122"/>
                 <a:cs typeface="Arial" pitchFamily="34" charset="-120"/>
               </a:rPr>
-              <a:t>No original PAN/OVD files, sender identities, independent source-of-funds proof, or external-bank posting confirmation.</a:t>
-            </a:r>
-            <a:endParaRPr lang="en-US" sz="1600" dirty="0"/>
+              <a:t>No original PAN/OVD files. All 10 distinct counterparties lack a mapped customer profile here; KYC is unknown. No independent funds proof or external-bank posting confirmation.</a:t>
+            </a:r>
+            <a:endParaRPr lang="en-US" sz="1500" dirty="0"/>
           </a:p>
         </p:txBody>
       </p:sp>
@@ -19900,7 +20130,7 @@
               <a:buNone/>
             </a:pPr>
             <a:r>
-              <a:rPr lang="en-US" sz="1600" dirty="0">
+              <a:rPr lang="en-US" sz="1500" dirty="0">
                 <a:solidFill>
                   <a:srgbClr val="172840"/>
                 </a:solidFill>
@@ -19910,14 +20140,14 @@
               </a:rPr>
               <a:t>Human actions and rationale</a:t>
             </a:r>
-            <a:endParaRPr lang="en-US" sz="1600" dirty="0"/>
+            <a:endParaRPr lang="en-US" sz="1500" dirty="0"/>
           </a:p>
           <a:p>
             <a:pPr indent="0" marL="0">
               <a:buNone/>
             </a:pPr>
             <a:r>
-              <a:rPr lang="en-US" sz="1600" dirty="0">
+              <a:rPr lang="en-US" sz="1500" dirty="0">
                 <a:solidFill>
                   <a:srgbClr val="172840"/>
                 </a:solidFill>
@@ -19925,16 +20155,16 @@
                 <a:ea typeface="Arial" pitchFamily="34" charset="-122"/>
                 <a:cs typeface="Arial" pitchFamily="34" charset="-120"/>
               </a:rPr>
-              <a:t>Audit events from each stage</a:t>
-            </a:r>
-            <a:endParaRPr lang="en-US" sz="1600" dirty="0"/>
+              <a:t>Audit events and rule settings</a:t>
+            </a:r>
+            <a:endParaRPr lang="en-US" sz="1500" dirty="0"/>
           </a:p>
           <a:p>
             <a:pPr indent="0" marL="0">
               <a:buNone/>
             </a:pPr>
             <a:r>
-              <a:rPr lang="en-US" sz="1600" dirty="0">
+              <a:rPr lang="en-US" sz="1500" dirty="0">
                 <a:solidFill>
                   <a:srgbClr val="172840"/>
                 </a:solidFill>
@@ -19942,16 +20172,16 @@
                 <a:ea typeface="Arial" pitchFamily="34" charset="-122"/>
                 <a:cs typeface="Arial" pitchFamily="34" charset="-120"/>
               </a:rPr>
-              <a:t>Admin rule settings and change history</a:t>
-            </a:r>
-            <a:endParaRPr lang="en-US" sz="1600" dirty="0"/>
+              <a:t>Gated fictional intake: 10 rows, 5 generated records and exact chunks per saved case</a:t>
+            </a:r>
+            <a:endParaRPr lang="en-US" sz="1500" dirty="0"/>
           </a:p>
           <a:p>
             <a:pPr indent="0" marL="0">
               <a:buNone/>
             </a:pPr>
             <a:r>
-              <a:rPr lang="en-US" sz="1600" dirty="0">
+              <a:rPr lang="en-US" sz="1500" dirty="0">
                 <a:solidFill>
                   <a:srgbClr val="172840"/>
                 </a:solidFill>
@@ -19959,9 +20189,9 @@
                 <a:ea typeface="Arial" pitchFamily="34" charset="-122"/>
                 <a:cs typeface="Arial" pitchFamily="34" charset="-120"/>
               </a:rPr>
-              <a:t>Mounted Railway volume preserves this state across deployments.</a:t>
-            </a:r>
-            <a:endParaRPr lang="en-US" sz="1600" dirty="0"/>
+              <a:t>Mounted volume preserves runtime state.</a:t>
+            </a:r>
+            <a:endParaRPr lang="en-US" sz="1500" dirty="0"/>
           </a:p>
         </p:txBody>
       </p:sp>
@@ -21743,7 +21973,7 @@
               <a:buNone/>
             </a:pPr>
             <a:r>
-              <a:rPr lang="en-US" sz="1500" b="1" dirty="0">
+              <a:rPr lang="en-US" sz="1400" b="1" dirty="0">
                 <a:solidFill>
                   <a:srgbClr val="10203B"/>
                 </a:solidFill>
@@ -21751,9 +21981,9 @@
                 <a:ea typeface="Arial" pitchFamily="34" charset="-122"/>
                 <a:cs typeface="Arial" pitchFamily="34" charset="-120"/>
               </a:rPr>
-              <a:t>agents/orchestrator.py calls these in order and writes stage events; the validator runs after stage 6.</a:t>
-            </a:r>
-            <a:endParaRPr lang="en-US" sz="1500" dirty="0"/>
+              <a:t>Source cases use this sequence. Gated intake cases use a separate calculated review, not these six stages.</a:t>
+            </a:r>
+            <a:endParaRPr lang="en-US" sz="1400" dirty="0"/>
           </a:p>
         </p:txBody>
       </p:sp>
@@ -22081,7 +22311,7 @@
                 <a:ea typeface="Arial" pitchFamily="34" charset="-122"/>
                 <a:cs typeface="Arial" pitchFamily="34" charset="-120"/>
               </a:rPr>
-              <a:t>Two corpora</a:t>
+              <a:t>Source sets</a:t>
             </a:r>
             <a:endParaRPr lang="en-US" sz="1700" dirty="0"/>
           </a:p>
@@ -22122,7 +22352,7 @@
                 <a:ea typeface="Arial" pitchFamily="34" charset="-122"/>
                 <a:cs typeface="Arial" pitchFamily="34" charset="-120"/>
               </a:rPr>
-              <a:t>24 guidance sources plus 1,770 generated case records.</a:t>
+              <a:t>Guidance, generated case records, and gated intake packets.</a:t>
             </a:r>
             <a:endParaRPr lang="en-US" sz="1300" dirty="0"/>
           </a:p>
@@ -22413,7 +22643,7 @@
                 <a:ea typeface="Arial" pitchFamily="34" charset="-122"/>
                 <a:cs typeface="Arial" pitchFamily="34" charset="-120"/>
               </a:rPr>
-              <a:t>Guidance: metadata + 2 sentences; case records: paragraphs.</a:t>
+              <a:t>Guidance: metadata + 2 sentences; case/intake: paragraphs.</a:t>
             </a:r>
             <a:endParaRPr lang="en-US" sz="1300" dirty="0"/>
           </a:p>
@@ -22704,7 +22934,7 @@
                 <a:ea typeface="Arial" pitchFamily="34" charset="-122"/>
                 <a:cs typeface="Arial" pitchFamily="34" charset="-120"/>
               </a:rPr>
-              <a:t>57 guidance + 4,282 case chunks; SQLite FTS5.</a:t>
+              <a:t>57 guidance + 4,282 source-case chunks; intake index separate.</a:t>
             </a:r>
             <a:endParaRPr lang="en-US" sz="1300" dirty="0"/>
           </a:p>
@@ -22995,7 +23225,7 @@
                 <a:ea typeface="Arial" pitchFamily="34" charset="-122"/>
                 <a:cs typeface="Arial" pitchFamily="34" charset="-120"/>
               </a:rPr>
-              <a:t>Scenario and case scope + BM25-ranked matches.</a:t>
+              <a:t>Scenario or case scope; FTS5 keyword matches.</a:t>
             </a:r>
             <a:endParaRPr lang="en-US" sz="1300" dirty="0"/>
           </a:p>

</xml_diff>

<commit_message>
Show verified public intake flow in walkthrough and deck
</commit_message>
<xml_diff>
--- a/Product Docs/InvestigateIQ_Technical_Flow.pptx
+++ b/Product Docs/InvestigateIQ_Technical_Flow.pptx
@@ -957,7 +957,7 @@
           <a:p>
             <a:r>
               <a:rPr lang="en-US" dirty="0"/>
-              <a:t>This slide describes the current local build, not the still-older public release. Do not imply tests prove fraud accuracy, business value or regulatory compliance. Original uploaded KYC files: zero. The feature-gated intake saves only numeric fictional batches with generated sample documents; its runtime cases do not run the existing six-agent/Gemini pipeline. Some source account IDs are ambiguous; ACC-1004 has two customer owners, so the code withholds attribution. The fictional matched cases intentionally have unknown external identities. A real rollout needs legal/compliance ownership, data permissions, secure ingestion, monitoring, retention and evaluation.</a:t>
+              <a:t>The public UI was smoke-tested on 2 October after commit 0501f6a: one saved fictional case survived reload, appeared in Queue, showed its exact FTS5 chunks and calculated review, and a named escalation appeared in Compliance. This does not prove persistence through another redeploy. Do not imply tests prove fraud accuracy, business value or regulatory compliance. Original uploaded KYC files: zero. Intake saves only numeric fictional batches and generated sample documents; its runtime cases do not run the existing six-agent/Gemini pipeline. ACC-1004 has two customer owners in the source, so code withholds attribution. A real rollout needs legal/compliance ownership, data permissions, authenticated ingestion, retention, official Indian regulatory review and evaluation.</a:t>
             </a:r>
             <a:endParaRPr lang="en-US" dirty="0"/>
           </a:p>
@@ -10687,7 +10687,7 @@
                 <a:ea typeface="Arial" pitchFamily="34" charset="-122"/>
                 <a:cs typeface="Arial" pitchFamily="34" charset="-120"/>
               </a:rPr>
-              <a:t>Verified locally</a:t>
+              <a:t>Verified locally + publicly</a:t>
             </a:r>
             <a:endParaRPr lang="en-US" sz="1700" dirty="0"/>
           </a:p>
@@ -10728,7 +10728,7 @@
                 <a:ea typeface="Arial" pitchFamily="34" charset="-122"/>
                 <a:cs typeface="Arial" pitchFamily="34" charset="-120"/>
               </a:rPr>
-              <a:t>98 automated tests pass.</a:t>
+              <a:t>103 automated tests pass locally; GitHub CI passes.</a:t>
             </a:r>
             <a:endParaRPr lang="en-US" sz="1600" dirty="0"/>
           </a:p>
@@ -10745,7 +10745,7 @@
                 <a:ea typeface="Arial" pitchFamily="34" charset="-122"/>
                 <a:cs typeface="Arial" pitchFamily="34" charset="-120"/>
               </a:rPr>
-              <a:t>44 source alerts, plus optional generated intake cases.</a:t>
+              <a:t>44 source alerts; public fictional intake adds saved cases.</a:t>
             </a:r>
             <a:endParaRPr lang="en-US" sz="1600" dirty="0"/>
           </a:p>
@@ -10762,7 +10762,7 @@
                 <a:ea typeface="Arial" pitchFamily="34" charset="-122"/>
                 <a:cs typeface="Arial" pitchFamily="34" charset="-120"/>
               </a:rPr>
-              <a:t>1,770 source case records, 4,282 source chunks; feature-gated intake packets add exact chunks separately.</a:t>
+              <a:t>Public QA: 10 rows, 5 generated records, 15 chunks; escalation reached Compliance.</a:t>
             </a:r>
             <a:endParaRPr lang="en-US" sz="1600" dirty="0"/>
           </a:p>

</xml_diff>